<commit_message>
Migdalei: equipos en las ubicaciones marcadas por el cliente (L2), fotos de los equipos en planos, visor, presentación y videos
Co-Authored-By: Claude Opus 5.5 <noreply@anthropic.com>
Claude-Session: https://claude.ai/code/session_015wmEUV9EbBvwtcXC6L5hB5
</commit_message>
<xml_diff>
--- a/migdalei/he/presentation_HE.pptx
+++ b/migdalei/he/presentation_HE.pptx
@@ -16,9 +16,10 @@
     <p:sldId id="264" r:id="rId10"/>
     <p:sldId id="265" r:id="rId11"/>
     <p:sldId id="266" r:id="rId12"/>
+    <p:sldId id="267" r:id="rId13"/>
   </p:sldIdLst>
   <p:notesMasterIdLst>
-    <p:notesMasterId r:id="rId13"/>
+    <p:notesMasterId r:id="rId14"/>
   </p:notesMasterIdLst>
   <p:sldSz cx="12192000" cy="6858000"/>
   <p:notesSz cx="6858000" cy="12192000"/>
@@ -117,39 +118,40 @@
   <p:extLst>
     <p:ext uri="{521415D9-36F7-43E2-AB2F-B90AF26B5E84}">
       <p14:sectionLst xmlns:p14="http://schemas.microsoft.com/office/powerpoint/2010/main">
-        <p14:section name="Proyecto" id="{44913bb2-387c-d7e9-0ac5-963e8dae3416}">
+        <p14:section name="Proyecto" id="{e5571f4e-6faf-eb68-c8cc-7f004ed22e86}">
           <p14:sldIdLst>
             <p14:sldId id="256"/>
             <p14:sldId id="257"/>
+            <p14:sldId id="258"/>
           </p14:sldIdLst>
         </p14:section>
-        <p14:section name="Planos 2D" id="{23b9ea50-09d0-e363-a7fc-c65c3062bda3}">
+        <p14:section name="Planos 2D" id="{96e472a3-4255-b451-8de1-51886acaf1bb}">
           <p14:sldIdLst>
-            <p14:sldId id="258"/>
             <p14:sldId id="259"/>
+            <p14:sldId id="260"/>
           </p14:sldIdLst>
         </p14:section>
-        <p14:section name="Departamentos" id="{15e76752-4fcd-8c00-04d3-eadca544d1d2}">
+        <p14:section name="Departamentos" id="{8658b466-1402-7da6-1b5f-0222dd1965e7}">
           <p14:sldIdLst>
-            <p14:sldId id="260"/>
             <p14:sldId id="261"/>
-          </p14:sldIdLst>
-        </p14:section>
-        <p14:section name="Planta baja" id="{c6e0e466-0fd2-d820-2173-2d9b0804f7cd}">
-          <p14:sldIdLst>
             <p14:sldId id="262"/>
           </p14:sldIdLst>
         </p14:section>
-        <p14:section name="Sistema" id="{6717cc11-2206-cc74-959c-7ad52414abb3}">
+        <p14:section name="Planta baja" id="{43c1542e-387d-6773-5543-dae2f4a24876}">
           <p14:sldIdLst>
             <p14:sldId id="263"/>
+          </p14:sldIdLst>
+        </p14:section>
+        <p14:section name="Sistema" id="{37bc5697-4622-04f2-c941-21f488ee1aa4}">
+          <p14:sldIdLst>
             <p14:sldId id="264"/>
             <p14:sldId id="265"/>
+            <p14:sldId id="266"/>
           </p14:sldIdLst>
         </p14:section>
-        <p14:section name="Entregables" id="{76a4aa5b-f41f-86cc-bd01-9d48561779ca}">
+        <p14:section name="Entregables" id="{6d1df4d3-b823-6262-31fb-401aee739fea}">
           <p14:sldIdLst>
-            <p14:sldId id="266"/>
+            <p14:sldId id="267"/>
           </p14:sldIdLst>
         </p14:section>
       </p14:sectionLst>
@@ -756,6 +758,94 @@
             <a:fld id="{F7021451-1387-4CA6-816F-3879F97B5CBC}" type="slidenum">
               <a:rPr lang="en-US"/>
               <a:t>11</a:t>
+            </a:fld>
+            <a:endParaRPr lang="en-US"/>
+          </a:p>
+        </p:txBody>
+      </p:sp>
+    </p:spTree>
+    <p:extLst>
+      <p:ext uri="{BB962C8B-B14F-4D97-AF65-F5344CB8AC3E}">
+        <p14:creationId xmlns:p14="http://schemas.microsoft.com/office/powerpoint/2010/main" val="1024086991"/>
+      </p:ext>
+    </p:extLst>
+  </p:cSld>
+  <p:clrMapOvr>
+    <a:masterClrMapping/>
+  </p:clrMapOvr>
+</p:notes>
+</file>
+
+<file path=ppt/notesSlides/notesSlide12.xml><?xml version="1.0" encoding="utf-8"?>
+<p:notes xmlns:a="http://schemas.openxmlformats.org/drawingml/2006/main" xmlns:r="http://schemas.openxmlformats.org/officeDocument/2006/relationships" xmlns:p="http://schemas.openxmlformats.org/presentationml/2006/main">
+  <p:cSld>
+    <p:spTree>
+      <p:nvGrpSpPr>
+        <p:cNvPr id="1" name=""/>
+        <p:cNvGrpSpPr/>
+        <p:nvPr/>
+      </p:nvGrpSpPr>
+      <p:grpSpPr>
+        <a:xfrm>
+          <a:off x="0" y="0"/>
+          <a:ext cx="0" cy="0"/>
+          <a:chOff x="0" y="0"/>
+          <a:chExt cx="0" cy="0"/>
+        </a:xfrm>
+      </p:grpSpPr>
+      <p:sp>
+        <p:nvSpPr>
+          <p:cNvPr id="2" name="Slide Image Placeholder 1"/>
+          <p:cNvSpPr>
+            <a:spLocks noGrp="1" noRot="1" noChangeAspect="1"/>
+          </p:cNvSpPr>
+          <p:nvPr>
+            <p:ph type="sldImg"/>
+          </p:nvPr>
+        </p:nvSpPr>
+        <p:spPr/>
+      </p:sp>
+      <p:sp>
+        <p:nvSpPr>
+          <p:cNvPr id="3" name="Notes Placeholder 2"/>
+          <p:cNvSpPr>
+            <a:spLocks noGrp="1"/>
+          </p:cNvSpPr>
+          <p:nvPr>
+            <p:ph type="body" idx="1"/>
+          </p:nvPr>
+        </p:nvSpPr>
+        <p:spPr/>
+        <p:txBody>
+          <a:bodyPr/>
+          <a:lstStyle/>
+          <a:p>
+            <a:r>
+              <a:rPr lang="en-US" dirty="0"/>
+              <a:t/>
+            </a:r>
+            <a:endParaRPr lang="en-US" dirty="0"/>
+          </a:p>
+        </p:txBody>
+      </p:sp>
+      <p:sp>
+        <p:nvSpPr>
+          <p:cNvPr id="4" name="Slide Number Placeholder 3"/>
+          <p:cNvSpPr>
+            <a:spLocks noGrp="1"/>
+          </p:cNvSpPr>
+          <p:nvPr>
+            <p:ph type="sldNum" sz="quarter" idx="10"/>
+          </p:nvPr>
+        </p:nvSpPr>
+        <p:spPr/>
+        <p:txBody>
+          <a:bodyPr/>
+          <a:lstStyle/>
+          <a:p>
+            <a:fld id="{F7021451-1387-4CA6-816F-3879F97B5CBC}" type="slidenum">
+              <a:rPr lang="en-US"/>
+              <a:t>12</a:t>
             </a:fld>
             <a:endParaRPr lang="en-US"/>
           </a:p>
@@ -2317,6 +2407,451 @@
                   <a:schemeClr val="tx1"/>
                 </a:solidFill>
               </a:rPr>
+              <a:t>חיווט בתלת-ממד והבניין</a:t>
+            </a:r>
+            <a:endParaRPr lang="en-US" sz="3000" dirty="0"/>
+          </a:p>
+        </p:txBody>
+      </p:sp>
+      <p:pic>
+        <p:nvPicPr>
+          <p:cNvPr id="3" name="render cableado" descr="/home/claude/mig2/dist/HE/renders/m3d_02_piso_cableado.png">    </p:cNvPr>
+          <p:cNvPicPr>
+            <a:picLocks noChangeAspect="1"/>
+          </p:cNvPicPr>
+          <p:nvPr/>
+        </p:nvPicPr>
+        <p:blipFill>
+          <a:blip r:embed="rId1"/>
+          <a:srcRect l="0" r="0" t="0" b="0"/>
+          <a:stretch/>
+        </p:blipFill>
+        <p:spPr>
+          <a:xfrm>
+            <a:off x="365760" y="1097280"/>
+            <a:ext cx="7315200" cy="3291840"/>
+          </a:xfrm>
+          <a:prstGeom prst="rect">
+            <a:avLst/>
+          </a:prstGeom>
+        </p:spPr>
+      </p:pic>
+      <p:pic>
+        <p:nvPicPr>
+          <p:cNvPr id="4" name="render edificio" descr="/home/claude/mig2/dist/HE/renders/m3d_08_edificio.png">    </p:cNvPr>
+          <p:cNvPicPr>
+            <a:picLocks noChangeAspect="1"/>
+          </p:cNvPicPr>
+          <p:nvPr/>
+        </p:nvPicPr>
+        <p:blipFill>
+          <a:blip r:embed="rId2"/>
+          <a:srcRect l="0" r="0" t="0" b="0"/>
+          <a:stretch/>
+        </p:blipFill>
+        <p:spPr>
+          <a:xfrm>
+            <a:off x="7863840" y="1097280"/>
+            <a:ext cx="3931920" cy="5212080"/>
+          </a:xfrm>
+          <a:prstGeom prst="rect">
+            <a:avLst/>
+          </a:prstGeom>
+        </p:spPr>
+      </p:pic>
+      <p:sp>
+        <p:nvSpPr>
+          <p:cNvPr id="5" name="color 0"/>
+          <p:cNvSpPr/>
+          <p:nvPr/>
+        </p:nvSpPr>
+        <p:spPr>
+          <a:xfrm>
+            <a:off x="548640" y="4709160"/>
+            <a:ext cx="502920" cy="109728"/>
+          </a:xfrm>
+          <a:prstGeom prst="rect">
+            <a:avLst/>
+          </a:prstGeom>
+          <a:solidFill>
+            <a:schemeClr val="accent2"/>
+          </a:solidFill>
+          <a:ln w="12700">
+            <a:solidFill>
+              <a:schemeClr val="accent2"/>
+            </a:solidFill>
+            <a:prstDash val="solid"/>
+          </a:ln>
+        </p:spPr>
+      </p:sp>
+      <p:sp>
+        <p:nvSpPr>
+          <p:cNvPr id="6" name="Text 2"/>
+          <p:cNvSpPr txBox="1"/>
+          <p:nvPr/>
+        </p:nvSpPr>
+        <p:spPr>
+          <a:xfrm>
+            <a:off x="548640" y="4892040"/>
+            <a:ext cx="2331720" cy="365760"/>
+          </a:xfrm>
+          <a:prstGeom prst="rect">
+            <a:avLst/>
+          </a:prstGeom>
+          <a:noFill/>
+          <a:ln/>
+        </p:spPr>
+        <p:txBody>
+          <a:bodyPr wrap="square" lIns="0" tIns="0" rIns="0" bIns="0" rtlCol="0" anchor="ctr"/>
+          <a:lstStyle/>
+          <a:p>
+            <a:pPr rtl="1" indent="0" marL="0">
+              <a:buNone/>
+            </a:pPr>
+            <a:r>
+              <a:rPr lang="en-US" sz="1400" b="1" dirty="0">
+                <a:solidFill>
+                  <a:schemeClr val="tx1"/>
+                </a:solidFill>
+              </a:rPr>
+              <a:t>Cat6 רדיאלי</a:t>
+            </a:r>
+            <a:endParaRPr lang="en-US" sz="1400" dirty="0"/>
+          </a:p>
+        </p:txBody>
+      </p:sp>
+      <p:sp>
+        <p:nvSpPr>
+          <p:cNvPr id="7" name="Text 3"/>
+          <p:cNvSpPr txBox="1"/>
+          <p:nvPr/>
+        </p:nvSpPr>
+        <p:spPr>
+          <a:xfrm>
+            <a:off x="548640" y="5303520"/>
+            <a:ext cx="2331720" cy="822960"/>
+          </a:xfrm>
+          <a:prstGeom prst="rect">
+            <a:avLst/>
+          </a:prstGeom>
+          <a:noFill/>
+          <a:ln/>
+        </p:spPr>
+        <p:txBody>
+          <a:bodyPr wrap="square" lIns="0" tIns="0" rIns="0" bIns="0" rtlCol="0" anchor="t"/>
+          <a:lstStyle/>
+          <a:p>
+            <a:pPr rtl="1" indent="0" marL="0">
+              <a:buNone/>
+            </a:pPr>
+            <a:r>
+              <a:rPr lang="en-US" sz="1200" dirty="0">
+                <a:solidFill>
+                  <a:schemeClr val="tx2"/>
+                </a:solidFill>
+              </a:rPr>
+              <a:t>כל התקן בדירה ל-LCom שלה</a:t>
+            </a:r>
+            <a:endParaRPr lang="en-US" sz="1200" dirty="0"/>
+          </a:p>
+        </p:txBody>
+      </p:sp>
+      <p:sp>
+        <p:nvSpPr>
+          <p:cNvPr id="8" name="color 1"/>
+          <p:cNvSpPr/>
+          <p:nvPr/>
+        </p:nvSpPr>
+        <p:spPr>
+          <a:xfrm>
+            <a:off x="3017520" y="4709160"/>
+            <a:ext cx="502920" cy="109728"/>
+          </a:xfrm>
+          <a:prstGeom prst="rect">
+            <a:avLst/>
+          </a:prstGeom>
+          <a:solidFill>
+            <a:schemeClr val="accent3"/>
+          </a:solidFill>
+          <a:ln w="12700">
+            <a:solidFill>
+              <a:schemeClr val="accent3"/>
+            </a:solidFill>
+            <a:prstDash val="solid"/>
+          </a:ln>
+        </p:spPr>
+      </p:sp>
+      <p:sp>
+        <p:nvSpPr>
+          <p:cNvPr id="9" name="Text 5"/>
+          <p:cNvSpPr txBox="1"/>
+          <p:nvPr/>
+        </p:nvSpPr>
+        <p:spPr>
+          <a:xfrm>
+            <a:off x="3017520" y="4892040"/>
+            <a:ext cx="2331720" cy="365760"/>
+          </a:xfrm>
+          <a:prstGeom prst="rect">
+            <a:avLst/>
+          </a:prstGeom>
+          <a:noFill/>
+          <a:ln/>
+        </p:spPr>
+        <p:txBody>
+          <a:bodyPr wrap="square" lIns="0" tIns="0" rIns="0" bIns="0" rtlCol="0" anchor="ctr"/>
+          <a:lstStyle/>
+          <a:p>
+            <a:pPr rtl="1" indent="0" marL="0">
+              <a:buNone/>
+            </a:pPr>
+            <a:r>
+              <a:rPr lang="en-US" sz="1400" b="1" dirty="0">
+                <a:solidFill>
+                  <a:schemeClr val="tx1"/>
+                </a:solidFill>
+              </a:rPr>
+              <a:t>Cat6 / Cat7 בשרשרת</a:t>
+            </a:r>
+            <a:endParaRPr lang="en-US" sz="1400" dirty="0"/>
+          </a:p>
+        </p:txBody>
+      </p:sp>
+      <p:sp>
+        <p:nvSpPr>
+          <p:cNvPr id="10" name="Text 6"/>
+          <p:cNvSpPr txBox="1"/>
+          <p:nvPr/>
+        </p:nvSpPr>
+        <p:spPr>
+          <a:xfrm>
+            <a:off x="3017520" y="5303520"/>
+            <a:ext cx="2331720" cy="822960"/>
+          </a:xfrm>
+          <a:prstGeom prst="rect">
+            <a:avLst/>
+          </a:prstGeom>
+          <a:noFill/>
+          <a:ln/>
+        </p:spPr>
+        <p:txBody>
+          <a:bodyPr wrap="square" lIns="0" tIns="0" rIns="0" bIns="0" rtlCol="0" anchor="t"/>
+          <a:lstStyle/>
+          <a:p>
+            <a:pPr rtl="1" indent="0" marL="0">
+              <a:buNone/>
+            </a:pPr>
+            <a:r>
+              <a:rPr lang="en-US" sz="1200" dirty="0">
+                <a:solidFill>
+                  <a:schemeClr val="tx2"/>
+                </a:solidFill>
+              </a:rPr>
+              <a:t>x01 ← x04 ← שירותים ציבוריים · x02 ← x03</a:t>
+            </a:r>
+            <a:endParaRPr lang="en-US" sz="1200" dirty="0"/>
+          </a:p>
+        </p:txBody>
+      </p:sp>
+      <p:sp>
+        <p:nvSpPr>
+          <p:cNvPr id="11" name="color 2"/>
+          <p:cNvSpPr/>
+          <p:nvPr/>
+        </p:nvSpPr>
+        <p:spPr>
+          <a:xfrm>
+            <a:off x="5486400" y="4709160"/>
+            <a:ext cx="502920" cy="109728"/>
+          </a:xfrm>
+          <a:prstGeom prst="rect">
+            <a:avLst/>
+          </a:prstGeom>
+          <a:solidFill>
+            <a:schemeClr val="accent4"/>
+          </a:solidFill>
+          <a:ln w="12700">
+            <a:solidFill>
+              <a:schemeClr val="accent4"/>
+            </a:solidFill>
+            <a:prstDash val="solid"/>
+          </a:ln>
+        </p:spPr>
+      </p:sp>
+      <p:sp>
+        <p:nvSpPr>
+          <p:cNvPr id="12" name="Text 8"/>
+          <p:cNvSpPr txBox="1"/>
+          <p:nvPr/>
+        </p:nvSpPr>
+        <p:spPr>
+          <a:xfrm>
+            <a:off x="5486400" y="4892040"/>
+            <a:ext cx="2331720" cy="365760"/>
+          </a:xfrm>
+          <a:prstGeom prst="rect">
+            <a:avLst/>
+          </a:prstGeom>
+          <a:noFill/>
+          <a:ln/>
+        </p:spPr>
+        <p:txBody>
+          <a:bodyPr wrap="square" lIns="0" tIns="0" rIns="0" bIns="0" rtlCol="0" anchor="ctr"/>
+          <a:lstStyle/>
+          <a:p>
+            <a:pPr rtl="1" indent="0" marL="0">
+              <a:buNone/>
+            </a:pPr>
+            <a:r>
+              <a:rPr lang="en-US" sz="1400" b="1" dirty="0">
+                <a:solidFill>
+                  <a:schemeClr val="tx1"/>
+                </a:solidFill>
+              </a:rPr>
+              <a:t>Cat6A / Cat7 רשת</a:t>
+            </a:r>
+            <a:endParaRPr lang="en-US" sz="1400" dirty="0"/>
+          </a:p>
+        </p:txBody>
+      </p:sp>
+      <p:sp>
+        <p:nvSpPr>
+          <p:cNvPr id="13" name="Text 9"/>
+          <p:cNvSpPr txBox="1"/>
+          <p:nvPr/>
+        </p:nvSpPr>
+        <p:spPr>
+          <a:xfrm>
+            <a:off x="5486400" y="5303520"/>
+            <a:ext cx="2331720" cy="822960"/>
+          </a:xfrm>
+          <a:prstGeom prst="rect">
+            <a:avLst/>
+          </a:prstGeom>
+          <a:noFill/>
+          <a:ln/>
+        </p:spPr>
+        <p:txBody>
+          <a:bodyPr wrap="square" lIns="0" tIns="0" rIns="0" bIns="0" rtlCol="0" anchor="t"/>
+          <a:lstStyle/>
+          <a:p>
+            <a:pPr rtl="1" indent="0" marL="0">
+              <a:buNone/>
+            </a:pPr>
+            <a:r>
+              <a:rPr lang="en-US" sz="1200" dirty="0">
+                <a:solidFill>
+                  <a:schemeClr val="tx2"/>
+                </a:solidFill>
+              </a:rPr>
+              <a:t>Buscomm ← מתג ← עמוד ← שרת</a:t>
+            </a:r>
+            <a:endParaRPr lang="en-US" sz="1200" dirty="0"/>
+          </a:p>
+        </p:txBody>
+      </p:sp>
+      <p:sp>
+        <p:nvSpPr>
+          <p:cNvPr id="25" name="Slide Number Placeholder 0"/>
+          <p:cNvSpPr>
+            <a:spLocks noGrp="1"/>
+          </p:cNvSpPr>
+          <p:nvPr>
+            <p:ph type="sldNum" sz="quarter" idx="4294967295"/>
+          </p:nvPr>
+        </p:nvSpPr>
+        <p:spPr>
+          <a:xfrm>
+            <a:off x="11155680" y="6446520"/>
+            <a:ext cx="457200" cy="274320"/>
+          </a:xfrm>
+          <a:prstGeom prst="rect">
+            <a:avLst/>
+          </a:prstGeom>
+          <a:extLst>
+            <a:ext uri="{C572A759-6A51-4108-AA02-DFA0A04FC94B}">
+              <ma14:wrappingTextBoxFlag xmlns:ma14="http://schemas.microsoft.com/office/mac/drawingml/2011/main" val="0"/>
+            </a:ext>
+          </a:extLst>
+        </p:spPr>
+        <p:txBody>
+          <a:bodyPr/>
+          <a:lstStyle>
+            <a:lvl1pPr>
+              <a:defRPr sz="1000">
+                <a:solidFill>
+                  <a:schemeClr val="tx2"/>
+                </a:solidFill>
+              </a:defRPr>
+            </a:lvl1pPr>
+          </a:lstStyle>
+          <a:p>
+            <a:pPr algn="r"/>
+            <a:fld id="{F7021451-1387-4CA6-816F-3879F97B5CBC}" type="slidenum">
+              <a:rPr b="0" lang="en-US"/>
+              <a:t>10</a:t>
+            </a:fld>
+            <a:endParaRPr lang="en-US"/>
+          </a:p>
+        </p:txBody>
+      </p:sp>
+    </p:spTree>
+  </p:cSld>
+  <p:clrMapOvr>
+    <a:masterClrMapping/>
+  </p:clrMapOvr>
+</p:sld>
+</file>
+
+<file path=ppt/slides/slide11.xml><?xml version="1.0" encoding="utf-8"?>
+<p:sld xmlns:a="http://schemas.openxmlformats.org/drawingml/2006/main" xmlns:r="http://schemas.openxmlformats.org/officeDocument/2006/relationships" xmlns:p="http://schemas.openxmlformats.org/presentationml/2006/main">
+  <p:cSld name="Slide 11">
+    <p:spTree>
+      <p:nvGrpSpPr>
+        <p:cNvPr id="1" name=""/>
+        <p:cNvGrpSpPr/>
+        <p:nvPr/>
+      </p:nvGrpSpPr>
+      <p:grpSpPr>
+        <a:xfrm>
+          <a:off x="0" y="0"/>
+          <a:ext cx="0" cy="0"/>
+          <a:chOff x="0" y="0"/>
+          <a:chExt cx="0" cy="0"/>
+        </a:xfrm>
+      </p:grpSpPr>
+      <p:sp>
+        <p:nvSpPr>
+          <p:cNvPr id="2" name="Text 0"/>
+          <p:cNvSpPr/>
+          <p:nvPr>
+            <p:ph idx="100" type="title" hasCustomPrompt="1"/>
+          </p:nvPr>
+        </p:nvSpPr>
+        <p:spPr>
+          <a:xfrm>
+            <a:off x="548640" y="320040"/>
+            <a:ext cx="11064240" cy="685800"/>
+          </a:xfrm>
+          <a:prstGeom prst="rect">
+            <a:avLst/>
+          </a:prstGeom>
+          <a:noFill/>
+          <a:ln/>
+        </p:spPr>
+        <p:txBody>
+          <a:bodyPr wrap="square" rtlCol="0" anchor="ctr"/>
+          <a:lstStyle/>
+          <a:p>
+            <a:pPr rtl="1" algn="r" indent="0" marL="0">
+              <a:buNone/>
+            </a:pPr>
+            <a:r>
+              <a:rPr lang="en-US" sz="3000" b="1" dirty="0">
+                <a:solidFill>
+                  <a:schemeClr val="tx1"/>
+                </a:solidFill>
+              </a:rPr>
               <a:t>רשימת חומרים – כל הבניין</a:t>
             </a:r>
             <a:endParaRPr lang="en-US" sz="3000" dirty="0"/>
@@ -2325,7 +2860,7 @@
       </p:sp>
       <p:graphicFrame>
         <p:nvGraphicFramePr>
-          <p:cNvPr id="11" name="tabla equipos"/>
+          <p:cNvPr id="12" name="tabla equipos"/>
           <p:cNvGraphicFramePr>
             <a:graphicFrameLocks noGrp="1"/>
           </p:cNvGraphicFramePr>
@@ -3423,7 +3958,7 @@
       </p:graphicFrame>
       <p:graphicFrame>
         <p:nvGraphicFramePr>
-          <p:cNvPr id="21" name="tabla cables"/>
+          <p:cNvPr id="23" name="tabla cables"/>
           <p:cNvGraphicFramePr>
             <a:graphicFrameLocks noGrp="1"/>
           </p:cNvGraphicFramePr>
@@ -3644,7 +4179,7 @@
                             <a:srgbClr val="1F2630"/>
                           </a:solidFill>
                         </a:rPr>
-                        <a:t>1880</a:t>
+                        <a:t>1700</a:t>
                       </a:r>
                       <a:endParaRPr lang="en-US" sz="1300" dirty="0"/>
                     </a:p>
@@ -4004,7 +4539,7 @@
             <a:pPr algn="r"/>
             <a:fld id="{F7021451-1387-4CA6-816F-3879F97B5CBC}" type="slidenum">
               <a:rPr b="0" lang="en-US"/>
-              <a:t>10</a:t>
+              <a:t>11</a:t>
             </a:fld>
             <a:endParaRPr lang="en-US"/>
           </a:p>
@@ -4018,9 +4553,9 @@
 </p:sld>
 </file>
 
-<file path=ppt/slides/slide11.xml><?xml version="1.0" encoding="utf-8"?>
+<file path=ppt/slides/slide12.xml><?xml version="1.0" encoding="utf-8"?>
 <p:sld xmlns:a="http://schemas.openxmlformats.org/drawingml/2006/main" xmlns:r="http://schemas.openxmlformats.org/officeDocument/2006/relationships" xmlns:p="http://schemas.openxmlformats.org/presentationml/2006/main">
-  <p:cSld name="Slide 11">
+  <p:cSld name="Slide 12">
     <p:spTree>
       <p:nvGrpSpPr>
         <p:cNvPr id="1" name=""/>
@@ -4164,7 +4699,7 @@
                   <a:schemeClr val="tx1"/>
                 </a:solidFill>
               </a:rPr>
-              <a:t>9 גיליונות A1: קומה טיפוסית, חיווט, דירות, קומת קרקע, תרשים אנכי, חומרים ותלת-ממד</a:t>
+              <a:t>11 גיליונות A1: קומה טיפוסית, ציוד עם תמונות, סימוני הלקוח, חיווט, דירות, קומת קרקע, תרשים אנכי, חומרים ותלת-ממד</a:t>
             </a:r>
             <a:endParaRPr lang="en-US" sz="1400" dirty="0"/>
           </a:p>
@@ -4694,7 +5229,7 @@
             <a:pPr algn="r"/>
             <a:fld id="{F7021451-1387-4CA6-816F-3879F97B5CBC}" type="slidenum">
               <a:rPr b="0" lang="en-US"/>
-              <a:t>11</a:t>
+              <a:t>12</a:t>
             </a:fld>
             <a:endParaRPr lang="en-US"/>
           </a:p>
@@ -5312,7 +5847,7 @@
                   <a:schemeClr val="tx1"/>
                 </a:solidFill>
               </a:rPr>
-              <a:t>קומה טיפוסית 1–8 – קריאת אחות</a:t>
+              <a:t>הציוד</a:t>
             </a:r>
             <a:endParaRPr lang="en-US" sz="3000" dirty="0"/>
           </a:p>
@@ -5348,15 +5883,40 @@
                   <a:schemeClr val="tx2"/>
                 </a:solidFill>
               </a:rPr>
-              <a:t>על התוכנית האדריכלית L5: טאבלט בכניסה, פנל קולי בסלון ובחדרי השינה, משיכות חבל בכל חדרי הרחצה</a:t>
+              <a:t>תמונות ייחוס של ACE BG / Advantecnia</a:t>
             </a:r>
             <a:endParaRPr lang="en-US" sz="1500" dirty="0"/>
           </a:p>
         </p:txBody>
+      </p:sp>
+      <p:sp>
+        <p:nvSpPr>
+          <p:cNvPr id="4" name="tarjeta 0"/>
+          <p:cNvSpPr/>
+          <p:nvPr/>
+        </p:nvSpPr>
+        <p:spPr>
+          <a:xfrm>
+            <a:off x="548640" y="1463040"/>
+            <a:ext cx="2651760" cy="4754880"/>
+          </a:xfrm>
+          <a:prstGeom prst="rect">
+            <a:avLst/>
+          </a:prstGeom>
+          <a:solidFill>
+            <a:srgbClr val="FFFFFF"/>
+          </a:solidFill>
+          <a:ln w="12700">
+            <a:solidFill>
+              <a:srgbClr val="DDE1E6"/>
+            </a:solidFill>
+            <a:prstDash val="solid"/>
+          </a:ln>
+        </p:spPr>
       </p:sp>
       <p:pic>
         <p:nvPicPr>
-          <p:cNvPr id="4" name="planta equipamiento" descr="/home/claude/mig2/dist/HE/renders/plan_equipamiento.png">    </p:cNvPr>
+          <p:cNvPr id="5" name="foto 0" descr="/home/claude/mig2/fotos/tirador.jpg">    </p:cNvPr>
           <p:cNvPicPr>
             <a:picLocks noChangeAspect="1"/>
           </p:cNvPicPr>
@@ -5369,14 +5929,590 @@
         </p:blipFill>
         <p:spPr>
           <a:xfrm>
-            <a:off x="365760" y="1417320"/>
-            <a:ext cx="11430000" cy="4892040"/>
+            <a:off x="640080" y="1554480"/>
+            <a:ext cx="2468880" cy="2651760"/>
           </a:xfrm>
           <a:prstGeom prst="rect">
             <a:avLst/>
           </a:prstGeom>
         </p:spPr>
       </p:pic>
+      <p:sp>
+        <p:nvSpPr>
+          <p:cNvPr id="6" name="Text 3"/>
+          <p:cNvSpPr txBox="1"/>
+          <p:nvPr/>
+        </p:nvSpPr>
+        <p:spPr>
+          <a:xfrm>
+            <a:off x="685800" y="4343400"/>
+            <a:ext cx="2377440" cy="548640"/>
+          </a:xfrm>
+          <a:prstGeom prst="rect">
+            <a:avLst/>
+          </a:prstGeom>
+          <a:noFill/>
+          <a:ln/>
+        </p:spPr>
+        <p:txBody>
+          <a:bodyPr wrap="square" lIns="0" tIns="0" rIns="0" bIns="0" rtlCol="0" anchor="t"/>
+          <a:lstStyle/>
+          <a:p>
+            <a:pPr rtl="1" indent="0" marL="0">
+              <a:buNone/>
+            </a:pPr>
+            <a:r>
+              <a:rPr lang="en-US" sz="1500" b="1" dirty="0">
+                <a:solidFill>
+                  <a:schemeClr val="tx1"/>
+                </a:solidFill>
+              </a:rPr>
+              <a:t>משיכת חבל</a:t>
+            </a:r>
+            <a:endParaRPr lang="en-US" sz="1500" dirty="0"/>
+          </a:p>
+        </p:txBody>
+      </p:sp>
+      <p:sp>
+        <p:nvSpPr>
+          <p:cNvPr id="7" name="Text 4"/>
+          <p:cNvSpPr txBox="1"/>
+          <p:nvPr/>
+        </p:nvSpPr>
+        <p:spPr>
+          <a:xfrm>
+            <a:off x="685800" y="4892040"/>
+            <a:ext cx="2377440" cy="548640"/>
+          </a:xfrm>
+          <a:prstGeom prst="rect">
+            <a:avLst/>
+          </a:prstGeom>
+          <a:noFill/>
+          <a:ln/>
+        </p:spPr>
+        <p:txBody>
+          <a:bodyPr wrap="square" lIns="0" tIns="0" rIns="0" bIns="0" rtlCol="0" anchor="t"/>
+          <a:lstStyle/>
+          <a:p>
+            <a:pPr rtl="1" indent="0" marL="0">
+              <a:buNone/>
+            </a:pPr>
+            <a:r>
+              <a:rPr lang="en-US" sz="1100" dirty="0">
+                <a:solidFill>
+                  <a:schemeClr val="tx2"/>
+                </a:solidFill>
+              </a:rPr>
+              <a:t>ACE40320303W · 1.85 מ'</a:t>
+            </a:r>
+            <a:endParaRPr lang="en-US" sz="1100" dirty="0"/>
+          </a:p>
+        </p:txBody>
+      </p:sp>
+      <p:sp>
+        <p:nvSpPr>
+          <p:cNvPr id="8" name="Text 5"/>
+          <p:cNvSpPr txBox="1"/>
+          <p:nvPr/>
+        </p:nvSpPr>
+        <p:spPr>
+          <a:xfrm>
+            <a:off x="685800" y="5440680"/>
+            <a:ext cx="2377440" cy="548640"/>
+          </a:xfrm>
+          <a:prstGeom prst="rect">
+            <a:avLst/>
+          </a:prstGeom>
+          <a:noFill/>
+          <a:ln/>
+        </p:spPr>
+        <p:txBody>
+          <a:bodyPr wrap="square" lIns="0" tIns="0" rIns="0" bIns="0" rtlCol="0" anchor="ctr"/>
+          <a:lstStyle/>
+          <a:p>
+            <a:pPr indent="0" marL="0">
+              <a:buNone/>
+            </a:pPr>
+            <a:r>
+              <a:rPr lang="en-US" sz="2600" b="1" dirty="0">
+                <a:solidFill>
+                  <a:schemeClr val="accent1"/>
+                </a:solidFill>
+              </a:rPr>
+              <a:t>138</a:t>
+            </a:r>
+            <a:endParaRPr lang="en-US" sz="2600" dirty="0"/>
+          </a:p>
+        </p:txBody>
+      </p:sp>
+      <p:sp>
+        <p:nvSpPr>
+          <p:cNvPr id="9" name="tarjeta 1"/>
+          <p:cNvSpPr/>
+          <p:nvPr/>
+        </p:nvSpPr>
+        <p:spPr>
+          <a:xfrm>
+            <a:off x="3383280" y="1463040"/>
+            <a:ext cx="2651760" cy="4754880"/>
+          </a:xfrm>
+          <a:prstGeom prst="rect">
+            <a:avLst/>
+          </a:prstGeom>
+          <a:solidFill>
+            <a:srgbClr val="FFFFFF"/>
+          </a:solidFill>
+          <a:ln w="12700">
+            <a:solidFill>
+              <a:srgbClr val="DDE1E6"/>
+            </a:solidFill>
+            <a:prstDash val="solid"/>
+          </a:ln>
+        </p:spPr>
+      </p:sp>
+      <p:pic>
+        <p:nvPicPr>
+          <p:cNvPr id="10" name="foto 1" descr="/home/claude/mig2/fotos/tablet.jpg">    </p:cNvPr>
+          <p:cNvPicPr>
+            <a:picLocks noChangeAspect="1"/>
+          </p:cNvPicPr>
+          <p:nvPr/>
+        </p:nvPicPr>
+        <p:blipFill>
+          <a:blip r:embed="rId2"/>
+          <a:srcRect l="0" r="0" t="0" b="0"/>
+          <a:stretch/>
+        </p:blipFill>
+        <p:spPr>
+          <a:xfrm>
+            <a:off x="3474720" y="1554480"/>
+            <a:ext cx="2468880" cy="2651760"/>
+          </a:xfrm>
+          <a:prstGeom prst="rect">
+            <a:avLst/>
+          </a:prstGeom>
+        </p:spPr>
+      </p:pic>
+      <p:sp>
+        <p:nvSpPr>
+          <p:cNvPr id="11" name="Text 7"/>
+          <p:cNvSpPr txBox="1"/>
+          <p:nvPr/>
+        </p:nvSpPr>
+        <p:spPr>
+          <a:xfrm>
+            <a:off x="3520440" y="4343400"/>
+            <a:ext cx="2377440" cy="548640"/>
+          </a:xfrm>
+          <a:prstGeom prst="rect">
+            <a:avLst/>
+          </a:prstGeom>
+          <a:noFill/>
+          <a:ln/>
+        </p:spPr>
+        <p:txBody>
+          <a:bodyPr wrap="square" lIns="0" tIns="0" rIns="0" bIns="0" rtlCol="0" anchor="t"/>
+          <a:lstStyle/>
+          <a:p>
+            <a:pPr rtl="1" indent="0" marL="0">
+              <a:buNone/>
+            </a:pPr>
+            <a:r>
+              <a:rPr lang="en-US" sz="1500" b="1" dirty="0">
+                <a:solidFill>
+                  <a:schemeClr val="tx1"/>
+                </a:solidFill>
+              </a:rPr>
+              <a:t>טאבלט בכניסה</a:t>
+            </a:r>
+            <a:endParaRPr lang="en-US" sz="1500" dirty="0"/>
+          </a:p>
+        </p:txBody>
+      </p:sp>
+      <p:sp>
+        <p:nvSpPr>
+          <p:cNvPr id="12" name="Text 8"/>
+          <p:cNvSpPr txBox="1"/>
+          <p:nvPr/>
+        </p:nvSpPr>
+        <p:spPr>
+          <a:xfrm>
+            <a:off x="3520440" y="4892040"/>
+            <a:ext cx="2377440" cy="548640"/>
+          </a:xfrm>
+          <a:prstGeom prst="rect">
+            <a:avLst/>
+          </a:prstGeom>
+          <a:noFill/>
+          <a:ln/>
+        </p:spPr>
+        <p:txBody>
+          <a:bodyPr wrap="square" lIns="0" tIns="0" rIns="0" bIns="0" rtlCol="0" anchor="t"/>
+          <a:lstStyle/>
+          <a:p>
+            <a:pPr rtl="1" indent="0" marL="0">
+              <a:buNone/>
+            </a:pPr>
+            <a:r>
+              <a:rPr lang="en-US" sz="1100" dirty="0">
+                <a:solidFill>
+                  <a:schemeClr val="tx2"/>
+                </a:solidFill>
+              </a:rPr>
+              <a:t>iPad / אנדרואיד · 1.40 מ'</a:t>
+            </a:r>
+            <a:endParaRPr lang="en-US" sz="1100" dirty="0"/>
+          </a:p>
+        </p:txBody>
+      </p:sp>
+      <p:sp>
+        <p:nvSpPr>
+          <p:cNvPr id="13" name="Text 9"/>
+          <p:cNvSpPr txBox="1"/>
+          <p:nvPr/>
+        </p:nvSpPr>
+        <p:spPr>
+          <a:xfrm>
+            <a:off x="3520440" y="5440680"/>
+            <a:ext cx="2377440" cy="548640"/>
+          </a:xfrm>
+          <a:prstGeom prst="rect">
+            <a:avLst/>
+          </a:prstGeom>
+          <a:noFill/>
+          <a:ln/>
+        </p:spPr>
+        <p:txBody>
+          <a:bodyPr wrap="square" lIns="0" tIns="0" rIns="0" bIns="0" rtlCol="0" anchor="ctr"/>
+          <a:lstStyle/>
+          <a:p>
+            <a:pPr indent="0" marL="0">
+              <a:buNone/>
+            </a:pPr>
+            <a:r>
+              <a:rPr lang="en-US" sz="2600" b="1" dirty="0">
+                <a:solidFill>
+                  <a:schemeClr val="accent1"/>
+                </a:solidFill>
+              </a:rPr>
+              <a:t>32</a:t>
+            </a:r>
+            <a:endParaRPr lang="en-US" sz="2600" dirty="0"/>
+          </a:p>
+        </p:txBody>
+      </p:sp>
+      <p:sp>
+        <p:nvSpPr>
+          <p:cNvPr id="14" name="tarjeta 2"/>
+          <p:cNvSpPr/>
+          <p:nvPr/>
+        </p:nvSpPr>
+        <p:spPr>
+          <a:xfrm>
+            <a:off x="6217920" y="1463040"/>
+            <a:ext cx="2651760" cy="4754880"/>
+          </a:xfrm>
+          <a:prstGeom prst="rect">
+            <a:avLst/>
+          </a:prstGeom>
+          <a:solidFill>
+            <a:srgbClr val="FFFFFF"/>
+          </a:solidFill>
+          <a:ln w="12700">
+            <a:solidFill>
+              <a:srgbClr val="DDE1E6"/>
+            </a:solidFill>
+            <a:prstDash val="solid"/>
+          </a:ln>
+        </p:spPr>
+      </p:sp>
+      <p:pic>
+        <p:nvPicPr>
+          <p:cNvPr id="15" name="foto 2" descr="/home/claude/mig2/fotos/luz.jpg">    </p:cNvPr>
+          <p:cNvPicPr>
+            <a:picLocks noChangeAspect="1"/>
+          </p:cNvPicPr>
+          <p:nvPr/>
+        </p:nvPicPr>
+        <p:blipFill>
+          <a:blip r:embed="rId3"/>
+          <a:srcRect l="0" r="0" t="0" b="0"/>
+          <a:stretch/>
+        </p:blipFill>
+        <p:spPr>
+          <a:xfrm>
+            <a:off x="6309360" y="1554480"/>
+            <a:ext cx="2468880" cy="2651760"/>
+          </a:xfrm>
+          <a:prstGeom prst="rect">
+            <a:avLst/>
+          </a:prstGeom>
+        </p:spPr>
+      </p:pic>
+      <p:sp>
+        <p:nvSpPr>
+          <p:cNvPr id="16" name="Text 11"/>
+          <p:cNvSpPr txBox="1"/>
+          <p:nvPr/>
+        </p:nvSpPr>
+        <p:spPr>
+          <a:xfrm>
+            <a:off x="6355080" y="4343400"/>
+            <a:ext cx="2377440" cy="548640"/>
+          </a:xfrm>
+          <a:prstGeom prst="rect">
+            <a:avLst/>
+          </a:prstGeom>
+          <a:noFill/>
+          <a:ln/>
+        </p:spPr>
+        <p:txBody>
+          <a:bodyPr wrap="square" lIns="0" tIns="0" rIns="0" bIns="0" rtlCol="0" anchor="t"/>
+          <a:lstStyle/>
+          <a:p>
+            <a:pPr rtl="1" indent="0" marL="0">
+              <a:buNone/>
+            </a:pPr>
+            <a:r>
+              <a:rPr lang="en-US" sz="1500" b="1" dirty="0">
+                <a:solidFill>
+                  <a:schemeClr val="tx1"/>
+                </a:solidFill>
+              </a:rPr>
+              <a:t>מנורת מסדרון</a:t>
+            </a:r>
+            <a:endParaRPr lang="en-US" sz="1500" dirty="0"/>
+          </a:p>
+        </p:txBody>
+      </p:sp>
+      <p:sp>
+        <p:nvSpPr>
+          <p:cNvPr id="17" name="Text 12"/>
+          <p:cNvSpPr txBox="1"/>
+          <p:nvPr/>
+        </p:nvSpPr>
+        <p:spPr>
+          <a:xfrm>
+            <a:off x="6355080" y="4892040"/>
+            <a:ext cx="2377440" cy="548640"/>
+          </a:xfrm>
+          <a:prstGeom prst="rect">
+            <a:avLst/>
+          </a:prstGeom>
+          <a:noFill/>
+          <a:ln/>
+        </p:spPr>
+        <p:txBody>
+          <a:bodyPr wrap="square" lIns="0" tIns="0" rIns="0" bIns="0" rtlCol="0" anchor="t"/>
+          <a:lstStyle/>
+          <a:p>
+            <a:pPr rtl="1" indent="0" marL="0">
+              <a:buNone/>
+            </a:pPr>
+            <a:r>
+              <a:rPr lang="en-US" sz="1100" dirty="0">
+                <a:solidFill>
+                  <a:schemeClr val="tx2"/>
+                </a:solidFill>
+              </a:rPr>
+              <a:t>ACE41020309 · שירותים ציבוריים</a:t>
+            </a:r>
+            <a:endParaRPr lang="en-US" sz="1100" dirty="0"/>
+          </a:p>
+        </p:txBody>
+      </p:sp>
+      <p:sp>
+        <p:nvSpPr>
+          <p:cNvPr id="18" name="Text 13"/>
+          <p:cNvSpPr txBox="1"/>
+          <p:nvPr/>
+        </p:nvSpPr>
+        <p:spPr>
+          <a:xfrm>
+            <a:off x="6355080" y="5440680"/>
+            <a:ext cx="2377440" cy="548640"/>
+          </a:xfrm>
+          <a:prstGeom prst="rect">
+            <a:avLst/>
+          </a:prstGeom>
+          <a:noFill/>
+          <a:ln/>
+        </p:spPr>
+        <p:txBody>
+          <a:bodyPr wrap="square" lIns="0" tIns="0" rIns="0" bIns="0" rtlCol="0" anchor="ctr"/>
+          <a:lstStyle/>
+          <a:p>
+            <a:pPr indent="0" marL="0">
+              <a:buNone/>
+            </a:pPr>
+            <a:r>
+              <a:rPr lang="en-US" sz="2600" b="1" dirty="0">
+                <a:solidFill>
+                  <a:schemeClr val="accent1"/>
+                </a:solidFill>
+              </a:rPr>
+              <a:t>10</a:t>
+            </a:r>
+            <a:endParaRPr lang="en-US" sz="2600" dirty="0"/>
+          </a:p>
+        </p:txBody>
+      </p:sp>
+      <p:sp>
+        <p:nvSpPr>
+          <p:cNvPr id="19" name="tarjeta 3"/>
+          <p:cNvSpPr/>
+          <p:nvPr/>
+        </p:nvSpPr>
+        <p:spPr>
+          <a:xfrm>
+            <a:off x="9052560" y="1463040"/>
+            <a:ext cx="2651760" cy="4754880"/>
+          </a:xfrm>
+          <a:prstGeom prst="rect">
+            <a:avLst/>
+          </a:prstGeom>
+          <a:solidFill>
+            <a:srgbClr val="FFFFFF"/>
+          </a:solidFill>
+          <a:ln w="12700">
+            <a:solidFill>
+              <a:srgbClr val="DDE1E6"/>
+            </a:solidFill>
+            <a:prstDash val="solid"/>
+          </a:ln>
+        </p:spPr>
+      </p:sp>
+      <p:pic>
+        <p:nvPicPr>
+          <p:cNvPr id="20" name="foto 3" descr="/home/claude/mig2/fotos/panel.jpg">    </p:cNvPr>
+          <p:cNvPicPr>
+            <a:picLocks noChangeAspect="1"/>
+          </p:cNvPicPr>
+          <p:nvPr/>
+        </p:nvPicPr>
+        <p:blipFill>
+          <a:blip r:embed="rId4"/>
+          <a:srcRect l="0" r="0" t="0" b="0"/>
+          <a:stretch/>
+        </p:blipFill>
+        <p:spPr>
+          <a:xfrm>
+            <a:off x="9144000" y="1554480"/>
+            <a:ext cx="2468880" cy="2651760"/>
+          </a:xfrm>
+          <a:prstGeom prst="rect">
+            <a:avLst/>
+          </a:prstGeom>
+        </p:spPr>
+      </p:pic>
+      <p:sp>
+        <p:nvSpPr>
+          <p:cNvPr id="21" name="Text 15"/>
+          <p:cNvSpPr txBox="1"/>
+          <p:nvPr/>
+        </p:nvSpPr>
+        <p:spPr>
+          <a:xfrm>
+            <a:off x="9189720" y="4343400"/>
+            <a:ext cx="2377440" cy="548640"/>
+          </a:xfrm>
+          <a:prstGeom prst="rect">
+            <a:avLst/>
+          </a:prstGeom>
+          <a:noFill/>
+          <a:ln/>
+        </p:spPr>
+        <p:txBody>
+          <a:bodyPr wrap="square" lIns="0" tIns="0" rIns="0" bIns="0" rtlCol="0" anchor="t"/>
+          <a:lstStyle/>
+          <a:p>
+            <a:pPr rtl="1" indent="0" marL="0">
+              <a:buNone/>
+            </a:pPr>
+            <a:r>
+              <a:rPr lang="en-US" sz="1500" b="1" dirty="0">
+                <a:solidFill>
+                  <a:schemeClr val="tx1"/>
+                </a:solidFill>
+              </a:rPr>
+              <a:t>פנל קולי עם לחצנים</a:t>
+            </a:r>
+            <a:endParaRPr lang="en-US" sz="1500" dirty="0"/>
+          </a:p>
+        </p:txBody>
+      </p:sp>
+      <p:sp>
+        <p:nvSpPr>
+          <p:cNvPr id="22" name="Text 16"/>
+          <p:cNvSpPr txBox="1"/>
+          <p:nvPr/>
+        </p:nvSpPr>
+        <p:spPr>
+          <a:xfrm>
+            <a:off x="9189720" y="4892040"/>
+            <a:ext cx="2377440" cy="548640"/>
+          </a:xfrm>
+          <a:prstGeom prst="rect">
+            <a:avLst/>
+          </a:prstGeom>
+          <a:noFill/>
+          <a:ln/>
+        </p:spPr>
+        <p:txBody>
+          <a:bodyPr wrap="square" lIns="0" tIns="0" rIns="0" bIns="0" rtlCol="0" anchor="t"/>
+          <a:lstStyle/>
+          <a:p>
+            <a:pPr rtl="1" indent="0" marL="0">
+              <a:buNone/>
+            </a:pPr>
+            <a:r>
+              <a:rPr lang="en-US" sz="1100" dirty="0">
+                <a:solidFill>
+                  <a:schemeClr val="tx2"/>
+                </a:solidFill>
+              </a:rPr>
+              <a:t>ACE82182451 · סלון וחדרי שינה</a:t>
+            </a:r>
+            <a:endParaRPr lang="en-US" sz="1100" dirty="0"/>
+          </a:p>
+        </p:txBody>
+      </p:sp>
+      <p:sp>
+        <p:nvSpPr>
+          <p:cNvPr id="23" name="Text 17"/>
+          <p:cNvSpPr txBox="1"/>
+          <p:nvPr/>
+        </p:nvSpPr>
+        <p:spPr>
+          <a:xfrm>
+            <a:off x="9189720" y="5440680"/>
+            <a:ext cx="2377440" cy="548640"/>
+          </a:xfrm>
+          <a:prstGeom prst="rect">
+            <a:avLst/>
+          </a:prstGeom>
+          <a:noFill/>
+          <a:ln/>
+        </p:spPr>
+        <p:txBody>
+          <a:bodyPr wrap="square" lIns="0" tIns="0" rIns="0" bIns="0" rtlCol="0" anchor="ctr"/>
+          <a:lstStyle/>
+          <a:p>
+            <a:pPr indent="0" marL="0">
+              <a:buNone/>
+            </a:pPr>
+            <a:r>
+              <a:rPr lang="en-US" sz="2600" b="1" dirty="0">
+                <a:solidFill>
+                  <a:schemeClr val="accent1"/>
+                </a:solidFill>
+              </a:rPr>
+              <a:t>80</a:t>
+            </a:r>
+            <a:endParaRPr lang="en-US" sz="2600" dirty="0"/>
+          </a:p>
+        </p:txBody>
+      </p:sp>
       <p:sp>
         <p:nvSpPr>
           <p:cNvPr id="25" name="Slide Number Placeholder 0"/>
@@ -5479,7 +6615,7 @@
                   <a:schemeClr val="tx1"/>
                 </a:solidFill>
               </a:rPr>
-              <a:t>קומה טיפוסית – חיווט</a:t>
+              <a:t>קומה טיפוסית 1–8 – קריאת אחות</a:t>
             </a:r>
             <a:endParaRPr lang="en-US" sz="3000" dirty="0"/>
           </a:p>
@@ -5487,41 +6623,14 @@
       </p:sp>
       <p:sp>
         <p:nvSpPr>
-          <p:cNvPr id="3" name="Shape 1"/>
-          <p:cNvSpPr/>
+          <p:cNvPr id="3" name="Text 1"/>
+          <p:cNvSpPr txBox="1"/>
           <p:nvPr/>
         </p:nvSpPr>
         <p:spPr>
           <a:xfrm>
             <a:off x="548640" y="960120"/>
-            <a:ext cx="2743200" cy="384048"/>
-          </a:xfrm>
-          <a:prstGeom prst="roundRect">
-            <a:avLst>
-              <a:gd name="adj" fmla="val 19048"/>
-            </a:avLst>
-          </a:prstGeom>
-          <a:solidFill>
-            <a:schemeClr val="accent2"/>
-          </a:solidFill>
-          <a:ln w="12700">
-            <a:solidFill>
-              <a:schemeClr val="accent2"/>
-            </a:solidFill>
-            <a:prstDash val="solid"/>
-          </a:ln>
-        </p:spPr>
-      </p:sp>
-      <p:sp>
-        <p:nvSpPr>
-          <p:cNvPr id="4" name="Text 2"/>
-          <p:cNvSpPr txBox="1"/>
-          <p:nvPr/>
-        </p:nvSpPr>
-        <p:spPr>
-          <a:xfrm>
-            <a:off x="548640" y="960120"/>
-            <a:ext cx="2743200" cy="384048"/>
+            <a:ext cx="11064240" cy="365760"/>
           </a:xfrm>
           <a:prstGeom prst="rect">
             <a:avLst/>
@@ -5533,150 +6642,24 @@
           <a:bodyPr wrap="square" lIns="0" tIns="0" rIns="0" bIns="0" rtlCol="0" anchor="ctr"/>
           <a:lstStyle/>
           <a:p>
-            <a:pPr rtl="1" algn="ctr" indent="0" marL="0">
+            <a:pPr rtl="1" indent="0" marL="0">
               <a:buNone/>
             </a:pPr>
             <a:r>
-              <a:rPr lang="en-US" sz="1300" b="1" dirty="0">
-                <a:solidFill>
-                  <a:schemeClr val="bg1"/>
+              <a:rPr lang="en-US" sz="1500" dirty="0">
+                <a:solidFill>
+                  <a:schemeClr val="tx2"/>
                 </a:solidFill>
               </a:rPr>
-              <a:t>ירוק · Cat6 רדיאלי</a:t>
-            </a:r>
-            <a:endParaRPr lang="en-US" sz="1300" dirty="0"/>
-          </a:p>
-        </p:txBody>
-      </p:sp>
-      <p:sp>
-        <p:nvSpPr>
-          <p:cNvPr id="5" name="Shape 3"/>
-          <p:cNvSpPr/>
-          <p:nvPr/>
-        </p:nvSpPr>
-        <p:spPr>
-          <a:xfrm>
-            <a:off x="3474720" y="960120"/>
-            <a:ext cx="3291840" cy="384048"/>
-          </a:xfrm>
-          <a:prstGeom prst="roundRect">
-            <a:avLst>
-              <a:gd name="adj" fmla="val 19048"/>
-            </a:avLst>
-          </a:prstGeom>
-          <a:solidFill>
-            <a:schemeClr val="accent3"/>
-          </a:solidFill>
-          <a:ln w="12700">
-            <a:solidFill>
-              <a:schemeClr val="accent3"/>
-            </a:solidFill>
-            <a:prstDash val="solid"/>
-          </a:ln>
-        </p:spPr>
-      </p:sp>
-      <p:sp>
-        <p:nvSpPr>
-          <p:cNvPr id="6" name="Text 4"/>
-          <p:cNvSpPr txBox="1"/>
-          <p:nvPr/>
-        </p:nvSpPr>
-        <p:spPr>
-          <a:xfrm>
-            <a:off x="3474720" y="960120"/>
-            <a:ext cx="3291840" cy="384048"/>
-          </a:xfrm>
-          <a:prstGeom prst="rect">
-            <a:avLst/>
-          </a:prstGeom>
-          <a:noFill/>
-          <a:ln/>
-        </p:spPr>
-        <p:txBody>
-          <a:bodyPr wrap="square" lIns="0" tIns="0" rIns="0" bIns="0" rtlCol="0" anchor="ctr"/>
-          <a:lstStyle/>
-          <a:p>
-            <a:pPr rtl="1" algn="ctr" indent="0" marL="0">
-              <a:buNone/>
-            </a:pPr>
-            <a:r>
-              <a:rPr lang="en-US" sz="1300" b="1" dirty="0">
-                <a:solidFill>
-                  <a:schemeClr val="bg1"/>
-                </a:solidFill>
-              </a:rPr>
-              <a:t>כתום · שרשרת LCom</a:t>
-            </a:r>
-            <a:endParaRPr lang="en-US" sz="1300" dirty="0"/>
-          </a:p>
-        </p:txBody>
-      </p:sp>
-      <p:sp>
-        <p:nvSpPr>
-          <p:cNvPr id="7" name="Shape 5"/>
-          <p:cNvSpPr/>
-          <p:nvPr/>
-        </p:nvSpPr>
-        <p:spPr>
-          <a:xfrm>
-            <a:off x="6949440" y="960120"/>
-            <a:ext cx="3474720" cy="384048"/>
-          </a:xfrm>
-          <a:prstGeom prst="roundRect">
-            <a:avLst>
-              <a:gd name="adj" fmla="val 19048"/>
-            </a:avLst>
-          </a:prstGeom>
-          <a:solidFill>
-            <a:schemeClr val="accent4"/>
-          </a:solidFill>
-          <a:ln w="12700">
-            <a:solidFill>
-              <a:schemeClr val="accent4"/>
-            </a:solidFill>
-            <a:prstDash val="solid"/>
-          </a:ln>
-        </p:spPr>
-      </p:sp>
-      <p:sp>
-        <p:nvSpPr>
-          <p:cNvPr id="8" name="Text 6"/>
-          <p:cNvSpPr txBox="1"/>
-          <p:nvPr/>
-        </p:nvSpPr>
-        <p:spPr>
-          <a:xfrm>
-            <a:off x="6949440" y="960120"/>
-            <a:ext cx="3474720" cy="384048"/>
-          </a:xfrm>
-          <a:prstGeom prst="rect">
-            <a:avLst/>
-          </a:prstGeom>
-          <a:noFill/>
-          <a:ln/>
-        </p:spPr>
-        <p:txBody>
-          <a:bodyPr wrap="square" lIns="0" tIns="0" rIns="0" bIns="0" rtlCol="0" anchor="ctr"/>
-          <a:lstStyle/>
-          <a:p>
-            <a:pPr rtl="1" algn="ctr" indent="0" marL="0">
-              <a:buNone/>
-            </a:pPr>
-            <a:r>
-              <a:rPr lang="en-US" sz="1300" b="1" dirty="0">
-                <a:solidFill>
-                  <a:schemeClr val="bg1"/>
-                </a:solidFill>
-              </a:rPr>
-              <a:t>אדום · רשת ועמוד</a:t>
-            </a:r>
-            <a:endParaRPr lang="en-US" sz="1300" dirty="0"/>
+              <a:t>על התוכנית האדריכלית L5: טאבלט בכניסה, פנל קולי בסלון ובחדרי השינה, משיכות חבל בכל חדרי הרחצה</a:t>
+            </a:r>
+            <a:endParaRPr lang="en-US" sz="1500" dirty="0"/>
           </a:p>
         </p:txBody>
       </p:sp>
       <p:pic>
         <p:nvPicPr>
-          <p:cNvPr id="9" name="planta cableado" descr="/home/claude/mig2/dist/HE/renders/plan_cableado.png">    </p:cNvPr>
+          <p:cNvPr id="4" name="planta equipamiento" descr="/home/claude/mig2/dist/HE/renders/plan_equipamiento.png">    </p:cNvPr>
           <p:cNvPicPr>
             <a:picLocks noChangeAspect="1"/>
           </p:cNvPicPr>
@@ -5689,8 +6672,8 @@
         </p:blipFill>
         <p:spPr>
           <a:xfrm>
-            <a:off x="365760" y="1463040"/>
-            <a:ext cx="11430000" cy="4846320"/>
+            <a:off x="365760" y="1417320"/>
+            <a:ext cx="11430000" cy="4892040"/>
           </a:xfrm>
           <a:prstGeom prst="rect">
             <a:avLst/>
@@ -5799,15 +6782,204 @@
                   <a:schemeClr val="tx1"/>
                 </a:solidFill>
               </a:rPr>
-              <a:t>בכניסה ובסלון</a:t>
+              <a:t>קומה טיפוסית – חיווט</a:t>
             </a:r>
             <a:endParaRPr lang="en-US" sz="3000" dirty="0"/>
+          </a:p>
+        </p:txBody>
+      </p:sp>
+      <p:sp>
+        <p:nvSpPr>
+          <p:cNvPr id="3" name="Shape 1"/>
+          <p:cNvSpPr/>
+          <p:nvPr/>
+        </p:nvSpPr>
+        <p:spPr>
+          <a:xfrm>
+            <a:off x="548640" y="960120"/>
+            <a:ext cx="2743200" cy="384048"/>
+          </a:xfrm>
+          <a:prstGeom prst="roundRect">
+            <a:avLst>
+              <a:gd name="adj" fmla="val 19048"/>
+            </a:avLst>
+          </a:prstGeom>
+          <a:solidFill>
+            <a:schemeClr val="accent2"/>
+          </a:solidFill>
+          <a:ln w="12700">
+            <a:solidFill>
+              <a:schemeClr val="accent2"/>
+            </a:solidFill>
+            <a:prstDash val="solid"/>
+          </a:ln>
+        </p:spPr>
+      </p:sp>
+      <p:sp>
+        <p:nvSpPr>
+          <p:cNvPr id="4" name="Text 2"/>
+          <p:cNvSpPr txBox="1"/>
+          <p:nvPr/>
+        </p:nvSpPr>
+        <p:spPr>
+          <a:xfrm>
+            <a:off x="548640" y="960120"/>
+            <a:ext cx="2743200" cy="384048"/>
+          </a:xfrm>
+          <a:prstGeom prst="rect">
+            <a:avLst/>
+          </a:prstGeom>
+          <a:noFill/>
+          <a:ln/>
+        </p:spPr>
+        <p:txBody>
+          <a:bodyPr wrap="square" lIns="0" tIns="0" rIns="0" bIns="0" rtlCol="0" anchor="ctr"/>
+          <a:lstStyle/>
+          <a:p>
+            <a:pPr rtl="1" algn="ctr" indent="0" marL="0">
+              <a:buNone/>
+            </a:pPr>
+            <a:r>
+              <a:rPr lang="en-US" sz="1300" b="1" dirty="0">
+                <a:solidFill>
+                  <a:schemeClr val="bg1"/>
+                </a:solidFill>
+              </a:rPr>
+              <a:t>ירוק · Cat6 רדיאלי</a:t>
+            </a:r>
+            <a:endParaRPr lang="en-US" sz="1300" dirty="0"/>
+          </a:p>
+        </p:txBody>
+      </p:sp>
+      <p:sp>
+        <p:nvSpPr>
+          <p:cNvPr id="5" name="Shape 3"/>
+          <p:cNvSpPr/>
+          <p:nvPr/>
+        </p:nvSpPr>
+        <p:spPr>
+          <a:xfrm>
+            <a:off x="3474720" y="960120"/>
+            <a:ext cx="3291840" cy="384048"/>
+          </a:xfrm>
+          <a:prstGeom prst="roundRect">
+            <a:avLst>
+              <a:gd name="adj" fmla="val 19048"/>
+            </a:avLst>
+          </a:prstGeom>
+          <a:solidFill>
+            <a:schemeClr val="accent3"/>
+          </a:solidFill>
+          <a:ln w="12700">
+            <a:solidFill>
+              <a:schemeClr val="accent3"/>
+            </a:solidFill>
+            <a:prstDash val="solid"/>
+          </a:ln>
+        </p:spPr>
+      </p:sp>
+      <p:sp>
+        <p:nvSpPr>
+          <p:cNvPr id="6" name="Text 4"/>
+          <p:cNvSpPr txBox="1"/>
+          <p:nvPr/>
+        </p:nvSpPr>
+        <p:spPr>
+          <a:xfrm>
+            <a:off x="3474720" y="960120"/>
+            <a:ext cx="3291840" cy="384048"/>
+          </a:xfrm>
+          <a:prstGeom prst="rect">
+            <a:avLst/>
+          </a:prstGeom>
+          <a:noFill/>
+          <a:ln/>
+        </p:spPr>
+        <p:txBody>
+          <a:bodyPr wrap="square" lIns="0" tIns="0" rIns="0" bIns="0" rtlCol="0" anchor="ctr"/>
+          <a:lstStyle/>
+          <a:p>
+            <a:pPr rtl="1" algn="ctr" indent="0" marL="0">
+              <a:buNone/>
+            </a:pPr>
+            <a:r>
+              <a:rPr lang="en-US" sz="1300" b="1" dirty="0">
+                <a:solidFill>
+                  <a:schemeClr val="bg1"/>
+                </a:solidFill>
+              </a:rPr>
+              <a:t>כתום · שרשרת LCom</a:t>
+            </a:r>
+            <a:endParaRPr lang="en-US" sz="1300" dirty="0"/>
+          </a:p>
+        </p:txBody>
+      </p:sp>
+      <p:sp>
+        <p:nvSpPr>
+          <p:cNvPr id="7" name="Shape 5"/>
+          <p:cNvSpPr/>
+          <p:nvPr/>
+        </p:nvSpPr>
+        <p:spPr>
+          <a:xfrm>
+            <a:off x="6949440" y="960120"/>
+            <a:ext cx="3474720" cy="384048"/>
+          </a:xfrm>
+          <a:prstGeom prst="roundRect">
+            <a:avLst>
+              <a:gd name="adj" fmla="val 19048"/>
+            </a:avLst>
+          </a:prstGeom>
+          <a:solidFill>
+            <a:schemeClr val="accent4"/>
+          </a:solidFill>
+          <a:ln w="12700">
+            <a:solidFill>
+              <a:schemeClr val="accent4"/>
+            </a:solidFill>
+            <a:prstDash val="solid"/>
+          </a:ln>
+        </p:spPr>
+      </p:sp>
+      <p:sp>
+        <p:nvSpPr>
+          <p:cNvPr id="8" name="Text 6"/>
+          <p:cNvSpPr txBox="1"/>
+          <p:nvPr/>
+        </p:nvSpPr>
+        <p:spPr>
+          <a:xfrm>
+            <a:off x="6949440" y="960120"/>
+            <a:ext cx="3474720" cy="384048"/>
+          </a:xfrm>
+          <a:prstGeom prst="rect">
+            <a:avLst/>
+          </a:prstGeom>
+          <a:noFill/>
+          <a:ln/>
+        </p:spPr>
+        <p:txBody>
+          <a:bodyPr wrap="square" lIns="0" tIns="0" rIns="0" bIns="0" rtlCol="0" anchor="ctr"/>
+          <a:lstStyle/>
+          <a:p>
+            <a:pPr rtl="1" algn="ctr" indent="0" marL="0">
+              <a:buNone/>
+            </a:pPr>
+            <a:r>
+              <a:rPr lang="en-US" sz="1300" b="1" dirty="0">
+                <a:solidFill>
+                  <a:schemeClr val="bg1"/>
+                </a:solidFill>
+              </a:rPr>
+              <a:t>אדום · רשת ועמוד</a:t>
+            </a:r>
+            <a:endParaRPr lang="en-US" sz="1300" dirty="0"/>
           </a:p>
         </p:txBody>
       </p:sp>
       <p:pic>
         <p:nvPicPr>
-          <p:cNvPr id="3" name="render tablet" descr="/home/claude/mig2/dist/HE/renders/m3d_04_tablet.png">    </p:cNvPr>
+          <p:cNvPr id="9" name="planta cableado" descr="/home/claude/mig2/dist/HE/renders/plan_cableado.png">    </p:cNvPr>
           <p:cNvPicPr>
             <a:picLocks noChangeAspect="1"/>
           </p:cNvPicPr>
@@ -5820,149 +6992,14 @@
         </p:blipFill>
         <p:spPr>
           <a:xfrm>
-            <a:off x="548640" y="1188720"/>
-            <a:ext cx="5486400" cy="2697480"/>
+            <a:off x="365760" y="1463040"/>
+            <a:ext cx="11430000" cy="4846320"/>
           </a:xfrm>
           <a:prstGeom prst="rect">
             <a:avLst/>
           </a:prstGeom>
         </p:spPr>
       </p:pic>
-      <p:pic>
-        <p:nvPicPr>
-          <p:cNvPr id="4" name="render salón" descr="/home/claude/mig2/dist/HE/renders/m3d_03_salon.png">    </p:cNvPr>
-          <p:cNvPicPr>
-            <a:picLocks noChangeAspect="1"/>
-          </p:cNvPicPr>
-          <p:nvPr/>
-        </p:nvPicPr>
-        <p:blipFill>
-          <a:blip r:embed="rId2"/>
-          <a:srcRect l="0" r="0" t="0" b="0"/>
-          <a:stretch/>
-        </p:blipFill>
-        <p:spPr>
-          <a:xfrm>
-            <a:off x="548640" y="3977640"/>
-            <a:ext cx="5486400" cy="2377440"/>
-          </a:xfrm>
-          <a:prstGeom prst="rect">
-            <a:avLst/>
-          </a:prstGeom>
-        </p:spPr>
-      </p:pic>
-      <p:sp>
-        <p:nvSpPr>
-          <p:cNvPr id="5" name="puntos"/>
-          <p:cNvSpPr txBox="1"/>
-          <p:nvPr/>
-        </p:nvSpPr>
-        <p:spPr>
-          <a:xfrm>
-            <a:off x="6309360" y="1234440"/>
-            <a:ext cx="5394960" cy="5120640"/>
-          </a:xfrm>
-          <a:prstGeom prst="rect">
-            <a:avLst/>
-          </a:prstGeom>
-          <a:noFill/>
-          <a:ln/>
-        </p:spPr>
-        <p:txBody>
-          <a:bodyPr wrap="square" rtlCol="0" anchor="t"/>
-          <a:lstStyle/>
-          <a:p>
-            <a:pPr rtl="1" marL="342900" indent="-342900">
-              <a:spcAft>
-                <a:spcPts val="800"/>
-              </a:spcAft>
-              <a:buSzPct val="100000"/>
-              <a:buChar char="•"/>
-            </a:pPr>
-            <a:r>
-              <a:rPr lang="en-US" sz="1500" dirty="0">
-                <a:solidFill>
-                  <a:schemeClr val="tx1"/>
-                </a:solidFill>
-              </a:rPr>
-              <a:t>טאבלט בכניסה לכל דירה (iPad / אנדרואיד, 1.40 מ'): קריאה ודיבור עם האחות</a:t>
-            </a:r>
-            <a:endParaRPr lang="en-US" sz="1500" dirty="0"/>
-          </a:p>
-          <a:p>
-            <a:pPr rtl="1" marL="342900" indent="-342900">
-              <a:spcAft>
-                <a:spcPts val="800"/>
-              </a:spcAft>
-              <a:buSzPct val="100000"/>
-              <a:buChar char="•"/>
-            </a:pPr>
-            <a:r>
-              <a:rPr lang="en-US" sz="1500" dirty="0">
-                <a:solidFill>
-                  <a:schemeClr val="tx1"/>
-                </a:solidFill>
-              </a:rPr>
-              <a:t>פנל קריאה קולי עם לחצנים ACE82182451 בסלון (1.30 מ')</a:t>
-            </a:r>
-            <a:endParaRPr lang="en-US" sz="1500" dirty="0"/>
-          </a:p>
-          <a:p>
-            <a:pPr rtl="1" marL="342900" indent="-342900">
-              <a:spcAft>
-                <a:spcPts val="800"/>
-              </a:spcAft>
-              <a:buSzPct val="100000"/>
-              <a:buChar char="•"/>
-            </a:pPr>
-            <a:r>
-              <a:rPr lang="en-US" sz="1500" dirty="0">
-                <a:solidFill>
-                  <a:schemeClr val="tx1"/>
-                </a:solidFill>
-              </a:rPr>
-              <a:t>LCom ACE71610003 בתקרת המבואה: מרכז את כל הדירה</a:t>
-            </a:r>
-            <a:endParaRPr lang="en-US" sz="1500" dirty="0"/>
-          </a:p>
-          <a:p>
-            <a:pPr rtl="1" marL="342900" indent="-342900">
-              <a:spcAft>
-                <a:spcPts val="800"/>
-              </a:spcAft>
-              <a:buSzPct val="100000"/>
-              <a:buChar char="•"/>
-            </a:pPr>
-            <a:r>
-              <a:rPr lang="en-US" sz="1500" dirty="0">
-                <a:solidFill>
-                  <a:schemeClr val="tx1"/>
-                </a:solidFill>
-              </a:rPr>
-              <a:t>דירות x01 ו-x02: חדר שינה אחד, סלון עם מטבח ו-2 חדרי רחצה</a:t>
-            </a:r>
-            <a:endParaRPr lang="en-US" sz="1500" dirty="0"/>
-          </a:p>
-          <a:p>
-            <a:pPr rtl="1" marL="342900" indent="-342900">
-              <a:spcAft>
-                <a:spcPts val="800"/>
-              </a:spcAft>
-              <a:buSzPct val="100000"/>
-              <a:buChar char="•"/>
-            </a:pPr>
-            <a:r>
-              <a:rPr lang="en-US" sz="1500" dirty="0">
-                <a:solidFill>
-                  <a:schemeClr val="tx1"/>
-                </a:solidFill>
-              </a:rPr>
-              <a:t>דירות x03 ו-x04: 2 חדרי שינה ו-2 חדרי רחצה</a:t>
-            </a:r>
-            <a:endParaRPr lang="en-US" sz="1500" dirty="0"/>
-          </a:p>
-        </p:txBody>
-      </p:sp>
       <p:sp>
         <p:nvSpPr>
           <p:cNvPr id="25" name="Slide Number Placeholder 0"/>
@@ -6065,7 +7102,7 @@
                   <a:schemeClr val="tx1"/>
                 </a:solidFill>
               </a:rPr>
-              <a:t>חדרי שינה וחדרי רחצה</a:t>
+              <a:t>בכניסה ובסלון</a:t>
             </a:r>
             <a:endParaRPr lang="en-US" sz="3000" dirty="0"/>
           </a:p>
@@ -6073,7 +7110,7 @@
       </p:sp>
       <p:pic>
         <p:nvPicPr>
-          <p:cNvPr id="3" name="render dormitorio" descr="/home/claude/mig2/dist/HE/renders/m3d_05_dormitorio.png">    </p:cNvPr>
+          <p:cNvPr id="3" name="render tablet" descr="/home/claude/mig2/dist/HE/renders/m3d_04_tablet.png">    </p:cNvPr>
           <p:cNvPicPr>
             <a:picLocks noChangeAspect="1"/>
           </p:cNvPicPr>
@@ -6087,7 +7124,7 @@
         <p:spPr>
           <a:xfrm>
             <a:off x="548640" y="1188720"/>
-            <a:ext cx="5486400" cy="4114800"/>
+            <a:ext cx="5486400" cy="2697480"/>
           </a:xfrm>
           <a:prstGeom prst="rect">
             <a:avLst/>
@@ -6096,7 +7133,7 @@
       </p:pic>
       <p:pic>
         <p:nvPicPr>
-          <p:cNvPr id="4" name="render baño" descr="/home/claude/mig2/dist/HE/renders/m3d_06_bano.png">    </p:cNvPr>
+          <p:cNvPr id="4" name="render salón" descr="/home/claude/mig2/dist/HE/renders/m3d_03_salon.png">    </p:cNvPr>
           <p:cNvPicPr>
             <a:picLocks noChangeAspect="1"/>
           </p:cNvPicPr>
@@ -6109,8 +7146,8 @@
         </p:blipFill>
         <p:spPr>
           <a:xfrm>
-            <a:off x="6172200" y="1188720"/>
-            <a:ext cx="5486400" cy="4114800"/>
+            <a:off x="548640" y="3977640"/>
+            <a:ext cx="5486400" cy="2377440"/>
           </a:xfrm>
           <a:prstGeom prst="rect">
             <a:avLst/>
@@ -6119,14 +7156,14 @@
       </p:pic>
       <p:sp>
         <p:nvSpPr>
-          <p:cNvPr id="5" name="Text 1"/>
+          <p:cNvPr id="5" name="puntos"/>
           <p:cNvSpPr txBox="1"/>
           <p:nvPr/>
         </p:nvSpPr>
         <p:spPr>
           <a:xfrm>
-            <a:off x="548640" y="5440680"/>
-            <a:ext cx="5486400" cy="731520"/>
+            <a:off x="6309360" y="1234440"/>
+            <a:ext cx="5394960" cy="5120640"/>
           </a:xfrm>
           <a:prstGeom prst="rect">
             <a:avLst/>
@@ -6135,57 +7172,97 @@
           <a:ln/>
         </p:spPr>
         <p:txBody>
-          <a:bodyPr wrap="square" lIns="0" tIns="0" rIns="0" bIns="0" rtlCol="0" anchor="t"/>
-          <a:lstStyle/>
-          <a:p>
-            <a:pPr rtl="1" indent="0" marL="0">
-              <a:buNone/>
+          <a:bodyPr wrap="square" rtlCol="0" anchor="t"/>
+          <a:lstStyle/>
+          <a:p>
+            <a:pPr rtl="1" marL="342900" indent="-342900">
+              <a:spcAft>
+                <a:spcPts val="800"/>
+              </a:spcAft>
+              <a:buSzPct val="100000"/>
+              <a:buChar char="•"/>
             </a:pPr>
             <a:r>
-              <a:rPr lang="en-US" sz="1300" dirty="0">
+              <a:rPr lang="en-US" sz="1500" dirty="0">
                 <a:solidFill>
                   <a:schemeClr val="tx1"/>
                 </a:solidFill>
               </a:rPr>
-              <a:t>פנל קולי עם לחצנים בכל חדר שינה, עם אגס קריאה ליד המיטה.</a:t>
-            </a:r>
-            <a:endParaRPr lang="en-US" sz="1300" dirty="0"/>
-          </a:p>
-        </p:txBody>
-      </p:sp>
-      <p:sp>
-        <p:nvSpPr>
-          <p:cNvPr id="6" name="Text 2"/>
-          <p:cNvSpPr txBox="1"/>
-          <p:nvPr/>
-        </p:nvSpPr>
-        <p:spPr>
-          <a:xfrm>
-            <a:off x="6172200" y="5440680"/>
-            <a:ext cx="5486400" cy="731520"/>
-          </a:xfrm>
-          <a:prstGeom prst="rect">
-            <a:avLst/>
-          </a:prstGeom>
-          <a:noFill/>
-          <a:ln/>
-        </p:spPr>
-        <p:txBody>
-          <a:bodyPr wrap="square" lIns="0" tIns="0" rIns="0" bIns="0" rtlCol="0" anchor="t"/>
-          <a:lstStyle/>
-          <a:p>
-            <a:pPr rtl="1" indent="0" marL="0">
-              <a:buNone/>
+              <a:t>טאבלט בכניסה לכל דירה (iPad / אנדרואיד, 1.40 מ'): קריאה ודיבור עם האחות</a:t>
+            </a:r>
+            <a:endParaRPr lang="en-US" sz="1500" dirty="0"/>
+          </a:p>
+          <a:p>
+            <a:pPr rtl="1" marL="342900" indent="-342900">
+              <a:spcAft>
+                <a:spcPts val="800"/>
+              </a:spcAft>
+              <a:buSzPct val="100000"/>
+              <a:buChar char="•"/>
             </a:pPr>
             <a:r>
-              <a:rPr lang="en-US" sz="1300" dirty="0">
+              <a:rPr lang="en-US" sz="1500" dirty="0">
                 <a:solidFill>
                   <a:schemeClr val="tx1"/>
                 </a:solidFill>
               </a:rPr>
-              <a:t>משיכות חבל ACE40320303W באסלה ובמקלחת בכל חדרי הרחצה, בגובה 1.85 מ'.</a:t>
-            </a:r>
-            <a:endParaRPr lang="en-US" sz="1300" dirty="0"/>
+              <a:t>פנל קריאה קולי עם לחצנים ACE82182451 בסלון (1.30 מ')</a:t>
+            </a:r>
+            <a:endParaRPr lang="en-US" sz="1500" dirty="0"/>
+          </a:p>
+          <a:p>
+            <a:pPr rtl="1" marL="342900" indent="-342900">
+              <a:spcAft>
+                <a:spcPts val="800"/>
+              </a:spcAft>
+              <a:buSzPct val="100000"/>
+              <a:buChar char="•"/>
+            </a:pPr>
+            <a:r>
+              <a:rPr lang="en-US" sz="1500" dirty="0">
+                <a:solidFill>
+                  <a:schemeClr val="tx1"/>
+                </a:solidFill>
+              </a:rPr>
+              <a:t>LCom ACE71610003 בתקרת המבואה: מרכז את כל הדירה</a:t>
+            </a:r>
+            <a:endParaRPr lang="en-US" sz="1500" dirty="0"/>
+          </a:p>
+          <a:p>
+            <a:pPr rtl="1" marL="342900" indent="-342900">
+              <a:spcAft>
+                <a:spcPts val="800"/>
+              </a:spcAft>
+              <a:buSzPct val="100000"/>
+              <a:buChar char="•"/>
+            </a:pPr>
+            <a:r>
+              <a:rPr lang="en-US" sz="1500" dirty="0">
+                <a:solidFill>
+                  <a:schemeClr val="tx1"/>
+                </a:solidFill>
+              </a:rPr>
+              <a:t>דירות x01 ו-x02: חדר שינה אחד, סלון עם מטבח ו-2 חדרי רחצה</a:t>
+            </a:r>
+            <a:endParaRPr lang="en-US" sz="1500" dirty="0"/>
+          </a:p>
+          <a:p>
+            <a:pPr rtl="1" marL="342900" indent="-342900">
+              <a:spcAft>
+                <a:spcPts val="800"/>
+              </a:spcAft>
+              <a:buSzPct val="100000"/>
+              <a:buChar char="•"/>
+            </a:pPr>
+            <a:r>
+              <a:rPr lang="en-US" sz="1500" dirty="0">
+                <a:solidFill>
+                  <a:schemeClr val="tx1"/>
+                </a:solidFill>
+              </a:rPr>
+              <a:t>דירות x03 ו-x04: 2 חדרי שינה ו-2 חדרי רחצה</a:t>
+            </a:r>
+            <a:endParaRPr lang="en-US" sz="1500" dirty="0"/>
           </a:p>
         </p:txBody>
       </p:sp>
@@ -6291,7 +7368,7 @@
                   <a:schemeClr val="tx1"/>
                 </a:solidFill>
               </a:rPr>
-              <a:t>קומת קרקע: קבלה עם עמדת אחות</a:t>
+              <a:t>חדרי שינה וחדרי רחצה</a:t>
             </a:r>
             <a:endParaRPr lang="en-US" sz="3000" dirty="0"/>
           </a:p>
@@ -6299,7 +7376,7 @@
       </p:sp>
       <p:pic>
         <p:nvPicPr>
-          <p:cNvPr id="3" name="render PB" descr="/home/claude/mig2/dist/HE/renders/m3d_09_pb.png">    </p:cNvPr>
+          <p:cNvPr id="3" name="render dormitorio" descr="/home/claude/mig2/dist/HE/renders/m3d_05_dormitorio.png">    </p:cNvPr>
           <p:cNvPicPr>
             <a:picLocks noChangeAspect="1"/>
           </p:cNvPicPr>
@@ -6313,7 +7390,7 @@
         <p:spPr>
           <a:xfrm>
             <a:off x="548640" y="1188720"/>
-            <a:ext cx="5852160" cy="4206240"/>
+            <a:ext cx="5486400" cy="4114800"/>
           </a:xfrm>
           <a:prstGeom prst="rect">
             <a:avLst/>
@@ -6322,7 +7399,7 @@
       </p:pic>
       <p:pic>
         <p:nvPicPr>
-          <p:cNvPr id="4" name="render desk" descr="/home/claude/mig2/dist/HE/renders/m3d_07_desk.png">    </p:cNvPr>
+          <p:cNvPr id="4" name="render baño" descr="/home/claude/mig2/dist/HE/renders/m3d_06_bano.png">    </p:cNvPr>
           <p:cNvPicPr>
             <a:picLocks noChangeAspect="1"/>
           </p:cNvPicPr>
@@ -6335,8 +7412,8 @@
         </p:blipFill>
         <p:spPr>
           <a:xfrm>
-            <a:off x="6537960" y="1188720"/>
-            <a:ext cx="5120640" cy="4206240"/>
+            <a:off x="6172200" y="1188720"/>
+            <a:ext cx="5486400" cy="4114800"/>
           </a:xfrm>
           <a:prstGeom prst="rect">
             <a:avLst/>
@@ -6351,8 +7428,8 @@
         </p:nvSpPr>
         <p:spPr>
           <a:xfrm>
-            <a:off x="548640" y="5532120"/>
-            <a:ext cx="11155680" cy="777240"/>
+            <a:off x="548640" y="5440680"/>
+            <a:ext cx="5486400" cy="731520"/>
           </a:xfrm>
           <a:prstGeom prst="rect">
             <a:avLst/>
@@ -6373,7 +7450,43 @@
                   <a:schemeClr val="tx1"/>
                 </a:solidFill>
               </a:rPr>
-              <a:t>עמדת אחות בקבלה עם טלפון שולחני אנדרואיד ACE52190200. מאחוריה המשרד עם השרת ACE51010103. 2 שירותים ציבוריים עם משיכת חבל ומנורת מסדרון. פריסה מוצעת: תעודכן לפי תוכנית הקרקע של האדריכל.</a:t>
+              <a:t>פנל קולי עם לחצנים בכל חדר שינה, עם אגס קריאה ליד המיטה.</a:t>
+            </a:r>
+            <a:endParaRPr lang="en-US" sz="1300" dirty="0"/>
+          </a:p>
+        </p:txBody>
+      </p:sp>
+      <p:sp>
+        <p:nvSpPr>
+          <p:cNvPr id="6" name="Text 2"/>
+          <p:cNvSpPr txBox="1"/>
+          <p:nvPr/>
+        </p:nvSpPr>
+        <p:spPr>
+          <a:xfrm>
+            <a:off x="6172200" y="5440680"/>
+            <a:ext cx="5486400" cy="731520"/>
+          </a:xfrm>
+          <a:prstGeom prst="rect">
+            <a:avLst/>
+          </a:prstGeom>
+          <a:noFill/>
+          <a:ln/>
+        </p:spPr>
+        <p:txBody>
+          <a:bodyPr wrap="square" lIns="0" tIns="0" rIns="0" bIns="0" rtlCol="0" anchor="t"/>
+          <a:lstStyle/>
+          <a:p>
+            <a:pPr rtl="1" indent="0" marL="0">
+              <a:buNone/>
+            </a:pPr>
+            <a:r>
+              <a:rPr lang="en-US" sz="1300" dirty="0">
+                <a:solidFill>
+                  <a:schemeClr val="tx1"/>
+                </a:solidFill>
+              </a:rPr>
+              <a:t>משיכות חבל ACE40320303W באסלה ובמקלחת בכל חדרי הרחצה, בגובה 1.85 מ'.</a:t>
             </a:r>
             <a:endParaRPr lang="en-US" sz="1300" dirty="0"/>
           </a:p>
@@ -6481,7 +7594,7 @@
                   <a:schemeClr val="tx1"/>
                 </a:solidFill>
               </a:rPr>
-              <a:t>טופולוגיה: מהדירה לעמדת האחות</a:t>
+              <a:t>קומת קרקע: קבלה עם עמדת אחות</a:t>
             </a:r>
             <a:endParaRPr lang="en-US" sz="3000" dirty="0"/>
           </a:p>
@@ -6489,7 +7602,7 @@
       </p:sp>
       <p:pic>
         <p:nvPicPr>
-          <p:cNvPr id="3" name="topologia" descr="/home/claude/mig2/dist/HE/renders/topologia.png">    </p:cNvPr>
+          <p:cNvPr id="3" name="render PB" descr="/home/claude/mig2/dist/HE/renders/m3d_09_pb.png">    </p:cNvPr>
           <p:cNvPicPr>
             <a:picLocks noChangeAspect="1"/>
           </p:cNvPicPr>
@@ -6502,85 +7615,47 @@
         </p:blipFill>
         <p:spPr>
           <a:xfrm>
-            <a:off x="365760" y="1097280"/>
-            <a:ext cx="11430000" cy="4023360"/>
+            <a:off x="548640" y="1188720"/>
+            <a:ext cx="5852160" cy="4206240"/>
           </a:xfrm>
           <a:prstGeom prst="rect">
             <a:avLst/>
           </a:prstGeom>
         </p:spPr>
       </p:pic>
-      <p:sp>
-        <p:nvSpPr>
-          <p:cNvPr id="4" name="paso 1"/>
-          <p:cNvSpPr/>
-          <p:nvPr/>
-        </p:nvSpPr>
-        <p:spPr>
-          <a:xfrm>
-            <a:off x="548640" y="5349240"/>
-            <a:ext cx="384048" cy="384048"/>
-          </a:xfrm>
-          <a:prstGeom prst="ellipse">
-            <a:avLst/>
-          </a:prstGeom>
-          <a:solidFill>
-            <a:schemeClr val="accent1"/>
-          </a:solidFill>
-          <a:ln w="12700">
-            <a:solidFill>
-              <a:schemeClr val="accent1"/>
-            </a:solidFill>
-            <a:prstDash val="solid"/>
-          </a:ln>
-        </p:spPr>
-      </p:sp>
-      <p:sp>
-        <p:nvSpPr>
-          <p:cNvPr id="5" name="Text 2"/>
+      <p:pic>
+        <p:nvPicPr>
+          <p:cNvPr id="4" name="render desk" descr="/home/claude/mig2/dist/HE/renders/m3d_07_desk.png">    </p:cNvPr>
+          <p:cNvPicPr>
+            <a:picLocks noChangeAspect="1"/>
+          </p:cNvPicPr>
+          <p:nvPr/>
+        </p:nvPicPr>
+        <p:blipFill>
+          <a:blip r:embed="rId2"/>
+          <a:srcRect l="0" r="0" t="0" b="0"/>
+          <a:stretch/>
+        </p:blipFill>
+        <p:spPr>
+          <a:xfrm>
+            <a:off x="6537960" y="1188720"/>
+            <a:ext cx="5120640" cy="4206240"/>
+          </a:xfrm>
+          <a:prstGeom prst="rect">
+            <a:avLst/>
+          </a:prstGeom>
+        </p:spPr>
+      </p:pic>
+      <p:sp>
+        <p:nvSpPr>
+          <p:cNvPr id="5" name="Text 1"/>
           <p:cNvSpPr txBox="1"/>
           <p:nvPr/>
         </p:nvSpPr>
         <p:spPr>
           <a:xfrm>
-            <a:off x="548640" y="5349240"/>
-            <a:ext cx="384048" cy="384048"/>
-          </a:xfrm>
-          <a:prstGeom prst="rect">
-            <a:avLst/>
-          </a:prstGeom>
-          <a:noFill/>
-          <a:ln/>
-        </p:spPr>
-        <p:txBody>
-          <a:bodyPr wrap="square" lIns="0" tIns="0" rIns="0" bIns="0" rtlCol="0" anchor="ctr"/>
-          <a:lstStyle/>
-          <a:p>
-            <a:pPr algn="ctr" indent="0" marL="0">
-              <a:buNone/>
-            </a:pPr>
-            <a:r>
-              <a:rPr lang="en-US" sz="1300" b="1" dirty="0">
-                <a:solidFill>
-                  <a:schemeClr val="bg1"/>
-                </a:solidFill>
-              </a:rPr>
-              <a:t>1</a:t>
-            </a:r>
-            <a:endParaRPr lang="en-US" sz="1300" dirty="0"/>
-          </a:p>
-        </p:txBody>
-      </p:sp>
-      <p:sp>
-        <p:nvSpPr>
-          <p:cNvPr id="6" name="Text 3"/>
-          <p:cNvSpPr txBox="1"/>
-          <p:nvPr/>
-        </p:nvSpPr>
-        <p:spPr>
-          <a:xfrm>
-            <a:off x="1005840" y="5257800"/>
-            <a:ext cx="1371600" cy="1005840"/>
+            <a:off x="548640" y="5532120"/>
+            <a:ext cx="11155680" cy="777240"/>
           </a:xfrm>
           <a:prstGeom prst="rect">
             <a:avLst/>
@@ -6596,499 +7671,14 @@
               <a:buNone/>
             </a:pPr>
             <a:r>
-              <a:rPr lang="en-US" sz="1100" dirty="0">
+              <a:rPr lang="en-US" sz="1300" dirty="0">
                 <a:solidFill>
                   <a:schemeClr val="tx1"/>
                 </a:solidFill>
               </a:rPr>
-              <a:t>הדייר קורא מהטאבלט, מהפנל או ממשיכת החבל</a:t>
-            </a:r>
-            <a:endParaRPr lang="en-US" sz="1100" dirty="0"/>
-          </a:p>
-        </p:txBody>
-      </p:sp>
-      <p:sp>
-        <p:nvSpPr>
-          <p:cNvPr id="7" name="paso 2"/>
-          <p:cNvSpPr/>
-          <p:nvPr/>
-        </p:nvSpPr>
-        <p:spPr>
-          <a:xfrm>
-            <a:off x="2423160" y="5349240"/>
-            <a:ext cx="384048" cy="384048"/>
-          </a:xfrm>
-          <a:prstGeom prst="ellipse">
-            <a:avLst/>
-          </a:prstGeom>
-          <a:solidFill>
-            <a:schemeClr val="accent1"/>
-          </a:solidFill>
-          <a:ln w="12700">
-            <a:solidFill>
-              <a:schemeClr val="accent1"/>
-            </a:solidFill>
-            <a:prstDash val="solid"/>
-          </a:ln>
-        </p:spPr>
-      </p:sp>
-      <p:sp>
-        <p:nvSpPr>
-          <p:cNvPr id="8" name="Text 5"/>
-          <p:cNvSpPr txBox="1"/>
-          <p:nvPr/>
-        </p:nvSpPr>
-        <p:spPr>
-          <a:xfrm>
-            <a:off x="2423160" y="5349240"/>
-            <a:ext cx="384048" cy="384048"/>
-          </a:xfrm>
-          <a:prstGeom prst="rect">
-            <a:avLst/>
-          </a:prstGeom>
-          <a:noFill/>
-          <a:ln/>
-        </p:spPr>
-        <p:txBody>
-          <a:bodyPr wrap="square" lIns="0" tIns="0" rIns="0" bIns="0" rtlCol="0" anchor="ctr"/>
-          <a:lstStyle/>
-          <a:p>
-            <a:pPr algn="ctr" indent="0" marL="0">
-              <a:buNone/>
-            </a:pPr>
-            <a:r>
-              <a:rPr lang="en-US" sz="1300" b="1" dirty="0">
-                <a:solidFill>
-                  <a:schemeClr val="bg1"/>
-                </a:solidFill>
-              </a:rPr>
-              <a:t>2</a:t>
+              <a:t>עמדת אחות בקבלה עם טלפון שולחני אנדרואיד ACE52190200. מאחוריה המשרד עם השרת ACE51010103. 2 שירותים ציבוריים עם משיכת חבל ומנורת מסדרון. פריסה מוצעת: תעודכן לפי תוכנית הקרקע של האדריכל.</a:t>
             </a:r>
             <a:endParaRPr lang="en-US" sz="1300" dirty="0"/>
-          </a:p>
-        </p:txBody>
-      </p:sp>
-      <p:sp>
-        <p:nvSpPr>
-          <p:cNvPr id="9" name="Text 6"/>
-          <p:cNvSpPr txBox="1"/>
-          <p:nvPr/>
-        </p:nvSpPr>
-        <p:spPr>
-          <a:xfrm>
-            <a:off x="2880360" y="5257800"/>
-            <a:ext cx="1371600" cy="1005840"/>
-          </a:xfrm>
-          <a:prstGeom prst="rect">
-            <a:avLst/>
-          </a:prstGeom>
-          <a:noFill/>
-          <a:ln/>
-        </p:spPr>
-        <p:txBody>
-          <a:bodyPr wrap="square" lIns="0" tIns="0" rIns="0" bIns="0" rtlCol="0" anchor="t"/>
-          <a:lstStyle/>
-          <a:p>
-            <a:pPr rtl="1" indent="0" marL="0">
-              <a:buNone/>
-            </a:pPr>
-            <a:r>
-              <a:rPr lang="en-US" sz="1100" dirty="0">
-                <a:solidFill>
-                  <a:schemeClr val="tx1"/>
-                </a:solidFill>
-              </a:rPr>
-              <a:t>Cat6 רדיאלי עד ה-LCom של הדירה</a:t>
-            </a:r>
-            <a:endParaRPr lang="en-US" sz="1100" dirty="0"/>
-          </a:p>
-        </p:txBody>
-      </p:sp>
-      <p:sp>
-        <p:nvSpPr>
-          <p:cNvPr id="10" name="paso 3"/>
-          <p:cNvSpPr/>
-          <p:nvPr/>
-        </p:nvSpPr>
-        <p:spPr>
-          <a:xfrm>
-            <a:off x="4297680" y="5349240"/>
-            <a:ext cx="384048" cy="384048"/>
-          </a:xfrm>
-          <a:prstGeom prst="ellipse">
-            <a:avLst/>
-          </a:prstGeom>
-          <a:solidFill>
-            <a:schemeClr val="accent1"/>
-          </a:solidFill>
-          <a:ln w="12700">
-            <a:solidFill>
-              <a:schemeClr val="accent1"/>
-            </a:solidFill>
-            <a:prstDash val="solid"/>
-          </a:ln>
-        </p:spPr>
-      </p:sp>
-      <p:sp>
-        <p:nvSpPr>
-          <p:cNvPr id="11" name="Text 8"/>
-          <p:cNvSpPr txBox="1"/>
-          <p:nvPr/>
-        </p:nvSpPr>
-        <p:spPr>
-          <a:xfrm>
-            <a:off x="4297680" y="5349240"/>
-            <a:ext cx="384048" cy="384048"/>
-          </a:xfrm>
-          <a:prstGeom prst="rect">
-            <a:avLst/>
-          </a:prstGeom>
-          <a:noFill/>
-          <a:ln/>
-        </p:spPr>
-        <p:txBody>
-          <a:bodyPr wrap="square" lIns="0" tIns="0" rIns="0" bIns="0" rtlCol="0" anchor="ctr"/>
-          <a:lstStyle/>
-          <a:p>
-            <a:pPr algn="ctr" indent="0" marL="0">
-              <a:buNone/>
-            </a:pPr>
-            <a:r>
-              <a:rPr lang="en-US" sz="1300" b="1" dirty="0">
-                <a:solidFill>
-                  <a:schemeClr val="bg1"/>
-                </a:solidFill>
-              </a:rPr>
-              <a:t>3</a:t>
-            </a:r>
-            <a:endParaRPr lang="en-US" sz="1300" dirty="0"/>
-          </a:p>
-        </p:txBody>
-      </p:sp>
-      <p:sp>
-        <p:nvSpPr>
-          <p:cNvPr id="12" name="Text 9"/>
-          <p:cNvSpPr txBox="1"/>
-          <p:nvPr/>
-        </p:nvSpPr>
-        <p:spPr>
-          <a:xfrm>
-            <a:off x="4754880" y="5257800"/>
-            <a:ext cx="1371600" cy="1005840"/>
-          </a:xfrm>
-          <a:prstGeom prst="rect">
-            <a:avLst/>
-          </a:prstGeom>
-          <a:noFill/>
-          <a:ln/>
-        </p:spPr>
-        <p:txBody>
-          <a:bodyPr wrap="square" lIns="0" tIns="0" rIns="0" bIns="0" rtlCol="0" anchor="t"/>
-          <a:lstStyle/>
-          <a:p>
-            <a:pPr rtl="1" indent="0" marL="0">
-              <a:buNone/>
-            </a:pPr>
-            <a:r>
-              <a:rPr lang="en-US" sz="1100" dirty="0">
-                <a:solidFill>
-                  <a:schemeClr val="tx1"/>
-                </a:solidFill>
-              </a:rPr>
-              <a:t>LCom ← LCom ← Buscomm בארון הקומה</a:t>
-            </a:r>
-            <a:endParaRPr lang="en-US" sz="1100" dirty="0"/>
-          </a:p>
-        </p:txBody>
-      </p:sp>
-      <p:sp>
-        <p:nvSpPr>
-          <p:cNvPr id="13" name="paso 4"/>
-          <p:cNvSpPr/>
-          <p:nvPr/>
-        </p:nvSpPr>
-        <p:spPr>
-          <a:xfrm>
-            <a:off x="6172200" y="5349240"/>
-            <a:ext cx="384048" cy="384048"/>
-          </a:xfrm>
-          <a:prstGeom prst="ellipse">
-            <a:avLst/>
-          </a:prstGeom>
-          <a:solidFill>
-            <a:schemeClr val="accent1"/>
-          </a:solidFill>
-          <a:ln w="12700">
-            <a:solidFill>
-              <a:schemeClr val="accent1"/>
-            </a:solidFill>
-            <a:prstDash val="solid"/>
-          </a:ln>
-        </p:spPr>
-      </p:sp>
-      <p:sp>
-        <p:nvSpPr>
-          <p:cNvPr id="14" name="Text 11"/>
-          <p:cNvSpPr txBox="1"/>
-          <p:nvPr/>
-        </p:nvSpPr>
-        <p:spPr>
-          <a:xfrm>
-            <a:off x="6172200" y="5349240"/>
-            <a:ext cx="384048" cy="384048"/>
-          </a:xfrm>
-          <a:prstGeom prst="rect">
-            <a:avLst/>
-          </a:prstGeom>
-          <a:noFill/>
-          <a:ln/>
-        </p:spPr>
-        <p:txBody>
-          <a:bodyPr wrap="square" lIns="0" tIns="0" rIns="0" bIns="0" rtlCol="0" anchor="ctr"/>
-          <a:lstStyle/>
-          <a:p>
-            <a:pPr algn="ctr" indent="0" marL="0">
-              <a:buNone/>
-            </a:pPr>
-            <a:r>
-              <a:rPr lang="en-US" sz="1300" b="1" dirty="0">
-                <a:solidFill>
-                  <a:schemeClr val="bg1"/>
-                </a:solidFill>
-              </a:rPr>
-              <a:t>4</a:t>
-            </a:r>
-            <a:endParaRPr lang="en-US" sz="1300" dirty="0"/>
-          </a:p>
-        </p:txBody>
-      </p:sp>
-      <p:sp>
-        <p:nvSpPr>
-          <p:cNvPr id="15" name="Text 12"/>
-          <p:cNvSpPr txBox="1"/>
-          <p:nvPr/>
-        </p:nvSpPr>
-        <p:spPr>
-          <a:xfrm>
-            <a:off x="6629400" y="5257800"/>
-            <a:ext cx="1371600" cy="1005840"/>
-          </a:xfrm>
-          <a:prstGeom prst="rect">
-            <a:avLst/>
-          </a:prstGeom>
-          <a:noFill/>
-          <a:ln/>
-        </p:spPr>
-        <p:txBody>
-          <a:bodyPr wrap="square" lIns="0" tIns="0" rIns="0" bIns="0" rtlCol="0" anchor="t"/>
-          <a:lstStyle/>
-          <a:p>
-            <a:pPr rtl="1" indent="0" marL="0">
-              <a:buNone/>
-            </a:pPr>
-            <a:r>
-              <a:rPr lang="en-US" sz="1100" dirty="0">
-                <a:solidFill>
-                  <a:schemeClr val="tx1"/>
-                </a:solidFill>
-              </a:rPr>
-              <a:t>Buscomm ← מתג PoE של הקומה</a:t>
-            </a:r>
-            <a:endParaRPr lang="en-US" sz="1100" dirty="0"/>
-          </a:p>
-        </p:txBody>
-      </p:sp>
-      <p:sp>
-        <p:nvSpPr>
-          <p:cNvPr id="16" name="paso 5"/>
-          <p:cNvSpPr/>
-          <p:nvPr/>
-        </p:nvSpPr>
-        <p:spPr>
-          <a:xfrm>
-            <a:off x="8046720" y="5349240"/>
-            <a:ext cx="384048" cy="384048"/>
-          </a:xfrm>
-          <a:prstGeom prst="ellipse">
-            <a:avLst/>
-          </a:prstGeom>
-          <a:solidFill>
-            <a:schemeClr val="accent1"/>
-          </a:solidFill>
-          <a:ln w="12700">
-            <a:solidFill>
-              <a:schemeClr val="accent1"/>
-            </a:solidFill>
-            <a:prstDash val="solid"/>
-          </a:ln>
-        </p:spPr>
-      </p:sp>
-      <p:sp>
-        <p:nvSpPr>
-          <p:cNvPr id="17" name="Text 14"/>
-          <p:cNvSpPr txBox="1"/>
-          <p:nvPr/>
-        </p:nvSpPr>
-        <p:spPr>
-          <a:xfrm>
-            <a:off x="8046720" y="5349240"/>
-            <a:ext cx="384048" cy="384048"/>
-          </a:xfrm>
-          <a:prstGeom prst="rect">
-            <a:avLst/>
-          </a:prstGeom>
-          <a:noFill/>
-          <a:ln/>
-        </p:spPr>
-        <p:txBody>
-          <a:bodyPr wrap="square" lIns="0" tIns="0" rIns="0" bIns="0" rtlCol="0" anchor="ctr"/>
-          <a:lstStyle/>
-          <a:p>
-            <a:pPr algn="ctr" indent="0" marL="0">
-              <a:buNone/>
-            </a:pPr>
-            <a:r>
-              <a:rPr lang="en-US" sz="1300" b="1" dirty="0">
-                <a:solidFill>
-                  <a:schemeClr val="bg1"/>
-                </a:solidFill>
-              </a:rPr>
-              <a:t>5</a:t>
-            </a:r>
-            <a:endParaRPr lang="en-US" sz="1300" dirty="0"/>
-          </a:p>
-        </p:txBody>
-      </p:sp>
-      <p:sp>
-        <p:nvSpPr>
-          <p:cNvPr id="18" name="Text 15"/>
-          <p:cNvSpPr txBox="1"/>
-          <p:nvPr/>
-        </p:nvSpPr>
-        <p:spPr>
-          <a:xfrm>
-            <a:off x="8503920" y="5257800"/>
-            <a:ext cx="1371600" cy="1005840"/>
-          </a:xfrm>
-          <a:prstGeom prst="rect">
-            <a:avLst/>
-          </a:prstGeom>
-          <a:noFill/>
-          <a:ln/>
-        </p:spPr>
-        <p:txBody>
-          <a:bodyPr wrap="square" lIns="0" tIns="0" rIns="0" bIns="0" rtlCol="0" anchor="t"/>
-          <a:lstStyle/>
-          <a:p>
-            <a:pPr rtl="1" indent="0" marL="0">
-              <a:buNone/>
-            </a:pPr>
-            <a:r>
-              <a:rPr lang="en-US" sz="1100" dirty="0">
-                <a:solidFill>
-                  <a:schemeClr val="tx1"/>
-                </a:solidFill>
-              </a:rPr>
-              <a:t>מתגים דרך העמוד ← שרת קרקע</a:t>
-            </a:r>
-            <a:endParaRPr lang="en-US" sz="1100" dirty="0"/>
-          </a:p>
-        </p:txBody>
-      </p:sp>
-      <p:sp>
-        <p:nvSpPr>
-          <p:cNvPr id="19" name="paso 6"/>
-          <p:cNvSpPr/>
-          <p:nvPr/>
-        </p:nvSpPr>
-        <p:spPr>
-          <a:xfrm>
-            <a:off x="9921240" y="5349240"/>
-            <a:ext cx="384048" cy="384048"/>
-          </a:xfrm>
-          <a:prstGeom prst="ellipse">
-            <a:avLst/>
-          </a:prstGeom>
-          <a:solidFill>
-            <a:schemeClr val="accent1"/>
-          </a:solidFill>
-          <a:ln w="12700">
-            <a:solidFill>
-              <a:schemeClr val="accent1"/>
-            </a:solidFill>
-            <a:prstDash val="solid"/>
-          </a:ln>
-        </p:spPr>
-      </p:sp>
-      <p:sp>
-        <p:nvSpPr>
-          <p:cNvPr id="20" name="Text 17"/>
-          <p:cNvSpPr txBox="1"/>
-          <p:nvPr/>
-        </p:nvSpPr>
-        <p:spPr>
-          <a:xfrm>
-            <a:off x="9921240" y="5349240"/>
-            <a:ext cx="384048" cy="384048"/>
-          </a:xfrm>
-          <a:prstGeom prst="rect">
-            <a:avLst/>
-          </a:prstGeom>
-          <a:noFill/>
-          <a:ln/>
-        </p:spPr>
-        <p:txBody>
-          <a:bodyPr wrap="square" lIns="0" tIns="0" rIns="0" bIns="0" rtlCol="0" anchor="ctr"/>
-          <a:lstStyle/>
-          <a:p>
-            <a:pPr algn="ctr" indent="0" marL="0">
-              <a:buNone/>
-            </a:pPr>
-            <a:r>
-              <a:rPr lang="en-US" sz="1300" b="1" dirty="0">
-                <a:solidFill>
-                  <a:schemeClr val="bg1"/>
-                </a:solidFill>
-              </a:rPr>
-              <a:t>6</a:t>
-            </a:r>
-            <a:endParaRPr lang="en-US" sz="1300" dirty="0"/>
-          </a:p>
-        </p:txBody>
-      </p:sp>
-      <p:sp>
-        <p:nvSpPr>
-          <p:cNvPr id="21" name="Text 18"/>
-          <p:cNvSpPr txBox="1"/>
-          <p:nvPr/>
-        </p:nvSpPr>
-        <p:spPr>
-          <a:xfrm>
-            <a:off x="10378440" y="5257800"/>
-            <a:ext cx="1371600" cy="1005840"/>
-          </a:xfrm>
-          <a:prstGeom prst="rect">
-            <a:avLst/>
-          </a:prstGeom>
-          <a:noFill/>
-          <a:ln/>
-        </p:spPr>
-        <p:txBody>
-          <a:bodyPr wrap="square" lIns="0" tIns="0" rIns="0" bIns="0" rtlCol="0" anchor="t"/>
-          <a:lstStyle/>
-          <a:p>
-            <a:pPr rtl="1" indent="0" marL="0">
-              <a:buNone/>
-            </a:pPr>
-            <a:r>
-              <a:rPr lang="en-US" sz="1100" dirty="0">
-                <a:solidFill>
-                  <a:schemeClr val="tx1"/>
-                </a:solidFill>
-              </a:rPr>
-              <a:t>שיחה קולית בטלפון האנדרואיד בעמדה</a:t>
-            </a:r>
-            <a:endParaRPr lang="en-US" sz="1100" dirty="0"/>
           </a:p>
         </p:txBody>
       </p:sp>
@@ -7194,7 +7784,7 @@
                   <a:schemeClr val="tx1"/>
                 </a:solidFill>
               </a:rPr>
-              <a:t>חיווט בתלת-ממד והבניין</a:t>
+              <a:t>טופולוגיה: מהדירה לעמדת האחות</a:t>
             </a:r>
             <a:endParaRPr lang="en-US" sz="3000" dirty="0"/>
           </a:p>
@@ -7202,7 +7792,7 @@
       </p:sp>
       <p:pic>
         <p:nvPicPr>
-          <p:cNvPr id="3" name="render cableado" descr="/home/claude/mig2/dist/HE/renders/m3d_02_piso_cableado.png">    </p:cNvPr>
+          <p:cNvPr id="3" name="topologia" descr="/home/claude/mig2/dist/HE/renders/topologia.png">    </p:cNvPr>
           <p:cNvPicPr>
             <a:picLocks noChangeAspect="1"/>
           </p:cNvPicPr>
@@ -7216,56 +7806,33 @@
         <p:spPr>
           <a:xfrm>
             <a:off x="365760" y="1097280"/>
-            <a:ext cx="7315200" cy="3291840"/>
+            <a:ext cx="11430000" cy="4023360"/>
           </a:xfrm>
           <a:prstGeom prst="rect">
             <a:avLst/>
           </a:prstGeom>
         </p:spPr>
       </p:pic>
-      <p:pic>
-        <p:nvPicPr>
-          <p:cNvPr id="4" name="render edificio" descr="/home/claude/mig2/dist/HE/renders/m3d_08_edificio.png">    </p:cNvPr>
-          <p:cNvPicPr>
-            <a:picLocks noChangeAspect="1"/>
-          </p:cNvPicPr>
-          <p:nvPr/>
-        </p:nvPicPr>
-        <p:blipFill>
-          <a:blip r:embed="rId2"/>
-          <a:srcRect l="0" r="0" t="0" b="0"/>
-          <a:stretch/>
-        </p:blipFill>
-        <p:spPr>
-          <a:xfrm>
-            <a:off x="7863840" y="1097280"/>
-            <a:ext cx="3931920" cy="5212080"/>
-          </a:xfrm>
-          <a:prstGeom prst="rect">
-            <a:avLst/>
-          </a:prstGeom>
-        </p:spPr>
-      </p:pic>
-      <p:sp>
-        <p:nvSpPr>
-          <p:cNvPr id="5" name="color 0"/>
+      <p:sp>
+        <p:nvSpPr>
+          <p:cNvPr id="4" name="paso 1"/>
           <p:cNvSpPr/>
           <p:nvPr/>
         </p:nvSpPr>
         <p:spPr>
           <a:xfrm>
-            <a:off x="548640" y="4709160"/>
-            <a:ext cx="502920" cy="109728"/>
-          </a:xfrm>
-          <a:prstGeom prst="rect">
+            <a:off x="548640" y="5349240"/>
+            <a:ext cx="384048" cy="384048"/>
+          </a:xfrm>
+          <a:prstGeom prst="ellipse">
             <a:avLst/>
           </a:prstGeom>
           <a:solidFill>
-            <a:schemeClr val="accent2"/>
+            <a:schemeClr val="accent1"/>
           </a:solidFill>
           <a:ln w="12700">
             <a:solidFill>
-              <a:schemeClr val="accent2"/>
+              <a:schemeClr val="accent1"/>
             </a:solidFill>
             <a:prstDash val="solid"/>
           </a:ln>
@@ -7273,14 +7840,14 @@
       </p:sp>
       <p:sp>
         <p:nvSpPr>
-          <p:cNvPr id="6" name="Text 2"/>
+          <p:cNvPr id="5" name="Text 2"/>
           <p:cNvSpPr txBox="1"/>
           <p:nvPr/>
         </p:nvSpPr>
         <p:spPr>
           <a:xfrm>
-            <a:off x="548640" y="4892040"/>
-            <a:ext cx="2331720" cy="365760"/>
+            <a:off x="548640" y="5349240"/>
+            <a:ext cx="384048" cy="384048"/>
           </a:xfrm>
           <a:prstGeom prst="rect">
             <a:avLst/>
@@ -7290,33 +7857,130 @@
         </p:spPr>
         <p:txBody>
           <a:bodyPr wrap="square" lIns="0" tIns="0" rIns="0" bIns="0" rtlCol="0" anchor="ctr"/>
+          <a:lstStyle/>
+          <a:p>
+            <a:pPr algn="ctr" indent="0" marL="0">
+              <a:buNone/>
+            </a:pPr>
+            <a:r>
+              <a:rPr lang="en-US" sz="1300" b="1" dirty="0">
+                <a:solidFill>
+                  <a:schemeClr val="bg1"/>
+                </a:solidFill>
+              </a:rPr>
+              <a:t>1</a:t>
+            </a:r>
+            <a:endParaRPr lang="en-US" sz="1300" dirty="0"/>
+          </a:p>
+        </p:txBody>
+      </p:sp>
+      <p:sp>
+        <p:nvSpPr>
+          <p:cNvPr id="6" name="Text 3"/>
+          <p:cNvSpPr txBox="1"/>
+          <p:nvPr/>
+        </p:nvSpPr>
+        <p:spPr>
+          <a:xfrm>
+            <a:off x="1005840" y="5257800"/>
+            <a:ext cx="1371600" cy="1005840"/>
+          </a:xfrm>
+          <a:prstGeom prst="rect">
+            <a:avLst/>
+          </a:prstGeom>
+          <a:noFill/>
+          <a:ln/>
+        </p:spPr>
+        <p:txBody>
+          <a:bodyPr wrap="square" lIns="0" tIns="0" rIns="0" bIns="0" rtlCol="0" anchor="t"/>
           <a:lstStyle/>
           <a:p>
             <a:pPr rtl="1" indent="0" marL="0">
               <a:buNone/>
             </a:pPr>
             <a:r>
-              <a:rPr lang="en-US" sz="1400" b="1" dirty="0">
+              <a:rPr lang="en-US" sz="1100" dirty="0">
                 <a:solidFill>
                   <a:schemeClr val="tx1"/>
                 </a:solidFill>
               </a:rPr>
-              <a:t>Cat6 רדיאלי</a:t>
-            </a:r>
-            <a:endParaRPr lang="en-US" sz="1400" dirty="0"/>
-          </a:p>
-        </p:txBody>
-      </p:sp>
-      <p:sp>
-        <p:nvSpPr>
-          <p:cNvPr id="7" name="Text 3"/>
+              <a:t>הדייר קורא מהטאבלט, מהפנל או ממשיכת החבל</a:t>
+            </a:r>
+            <a:endParaRPr lang="en-US" sz="1100" dirty="0"/>
+          </a:p>
+        </p:txBody>
+      </p:sp>
+      <p:sp>
+        <p:nvSpPr>
+          <p:cNvPr id="7" name="paso 2"/>
+          <p:cNvSpPr/>
+          <p:nvPr/>
+        </p:nvSpPr>
+        <p:spPr>
+          <a:xfrm>
+            <a:off x="2423160" y="5349240"/>
+            <a:ext cx="384048" cy="384048"/>
+          </a:xfrm>
+          <a:prstGeom prst="ellipse">
+            <a:avLst/>
+          </a:prstGeom>
+          <a:solidFill>
+            <a:schemeClr val="accent1"/>
+          </a:solidFill>
+          <a:ln w="12700">
+            <a:solidFill>
+              <a:schemeClr val="accent1"/>
+            </a:solidFill>
+            <a:prstDash val="solid"/>
+          </a:ln>
+        </p:spPr>
+      </p:sp>
+      <p:sp>
+        <p:nvSpPr>
+          <p:cNvPr id="8" name="Text 5"/>
           <p:cNvSpPr txBox="1"/>
           <p:nvPr/>
         </p:nvSpPr>
         <p:spPr>
           <a:xfrm>
-            <a:off x="548640" y="5303520"/>
-            <a:ext cx="2331720" cy="822960"/>
+            <a:off x="2423160" y="5349240"/>
+            <a:ext cx="384048" cy="384048"/>
+          </a:xfrm>
+          <a:prstGeom prst="rect">
+            <a:avLst/>
+          </a:prstGeom>
+          <a:noFill/>
+          <a:ln/>
+        </p:spPr>
+        <p:txBody>
+          <a:bodyPr wrap="square" lIns="0" tIns="0" rIns="0" bIns="0" rtlCol="0" anchor="ctr"/>
+          <a:lstStyle/>
+          <a:p>
+            <a:pPr algn="ctr" indent="0" marL="0">
+              <a:buNone/>
+            </a:pPr>
+            <a:r>
+              <a:rPr lang="en-US" sz="1300" b="1" dirty="0">
+                <a:solidFill>
+                  <a:schemeClr val="bg1"/>
+                </a:solidFill>
+              </a:rPr>
+              <a:t>2</a:t>
+            </a:r>
+            <a:endParaRPr lang="en-US" sz="1300" dirty="0"/>
+          </a:p>
+        </p:txBody>
+      </p:sp>
+      <p:sp>
+        <p:nvSpPr>
+          <p:cNvPr id="9" name="Text 6"/>
+          <p:cNvSpPr txBox="1"/>
+          <p:nvPr/>
+        </p:nvSpPr>
+        <p:spPr>
+          <a:xfrm>
+            <a:off x="2880360" y="5257800"/>
+            <a:ext cx="1371600" cy="1005840"/>
           </a:xfrm>
           <a:prstGeom prst="rect">
             <a:avLst/>
@@ -7332,37 +7996,37 @@
               <a:buNone/>
             </a:pPr>
             <a:r>
-              <a:rPr lang="en-US" sz="1200" dirty="0">
-                <a:solidFill>
-                  <a:schemeClr val="tx2"/>
+              <a:rPr lang="en-US" sz="1100" dirty="0">
+                <a:solidFill>
+                  <a:schemeClr val="tx1"/>
                 </a:solidFill>
               </a:rPr>
-              <a:t>כל התקן בדירה ל-LCom שלה</a:t>
-            </a:r>
-            <a:endParaRPr lang="en-US" sz="1200" dirty="0"/>
-          </a:p>
-        </p:txBody>
-      </p:sp>
-      <p:sp>
-        <p:nvSpPr>
-          <p:cNvPr id="8" name="color 1"/>
+              <a:t>Cat6 רדיאלי עד ה-LCom של הדירה</a:t>
+            </a:r>
+            <a:endParaRPr lang="en-US" sz="1100" dirty="0"/>
+          </a:p>
+        </p:txBody>
+      </p:sp>
+      <p:sp>
+        <p:nvSpPr>
+          <p:cNvPr id="10" name="paso 3"/>
           <p:cNvSpPr/>
           <p:nvPr/>
         </p:nvSpPr>
         <p:spPr>
           <a:xfrm>
-            <a:off x="3017520" y="4709160"/>
-            <a:ext cx="502920" cy="109728"/>
-          </a:xfrm>
-          <a:prstGeom prst="rect">
+            <a:off x="4297680" y="5349240"/>
+            <a:ext cx="384048" cy="384048"/>
+          </a:xfrm>
+          <a:prstGeom prst="ellipse">
             <a:avLst/>
           </a:prstGeom>
           <a:solidFill>
-            <a:schemeClr val="accent3"/>
+            <a:schemeClr val="accent1"/>
           </a:solidFill>
           <a:ln w="12700">
             <a:solidFill>
-              <a:schemeClr val="accent3"/>
+              <a:schemeClr val="accent1"/>
             </a:solidFill>
             <a:prstDash val="solid"/>
           </a:ln>
@@ -7370,14 +8034,14 @@
       </p:sp>
       <p:sp>
         <p:nvSpPr>
-          <p:cNvPr id="9" name="Text 5"/>
+          <p:cNvPr id="11" name="Text 8"/>
           <p:cNvSpPr txBox="1"/>
           <p:nvPr/>
         </p:nvSpPr>
         <p:spPr>
           <a:xfrm>
-            <a:off x="3017520" y="4892040"/>
-            <a:ext cx="2331720" cy="365760"/>
+            <a:off x="4297680" y="5349240"/>
+            <a:ext cx="384048" cy="384048"/>
           </a:xfrm>
           <a:prstGeom prst="rect">
             <a:avLst/>
@@ -7387,33 +8051,130 @@
         </p:spPr>
         <p:txBody>
           <a:bodyPr wrap="square" lIns="0" tIns="0" rIns="0" bIns="0" rtlCol="0" anchor="ctr"/>
+          <a:lstStyle/>
+          <a:p>
+            <a:pPr algn="ctr" indent="0" marL="0">
+              <a:buNone/>
+            </a:pPr>
+            <a:r>
+              <a:rPr lang="en-US" sz="1300" b="1" dirty="0">
+                <a:solidFill>
+                  <a:schemeClr val="bg1"/>
+                </a:solidFill>
+              </a:rPr>
+              <a:t>3</a:t>
+            </a:r>
+            <a:endParaRPr lang="en-US" sz="1300" dirty="0"/>
+          </a:p>
+        </p:txBody>
+      </p:sp>
+      <p:sp>
+        <p:nvSpPr>
+          <p:cNvPr id="12" name="Text 9"/>
+          <p:cNvSpPr txBox="1"/>
+          <p:nvPr/>
+        </p:nvSpPr>
+        <p:spPr>
+          <a:xfrm>
+            <a:off x="4754880" y="5257800"/>
+            <a:ext cx="1371600" cy="1005840"/>
+          </a:xfrm>
+          <a:prstGeom prst="rect">
+            <a:avLst/>
+          </a:prstGeom>
+          <a:noFill/>
+          <a:ln/>
+        </p:spPr>
+        <p:txBody>
+          <a:bodyPr wrap="square" lIns="0" tIns="0" rIns="0" bIns="0" rtlCol="0" anchor="t"/>
           <a:lstStyle/>
           <a:p>
             <a:pPr rtl="1" indent="0" marL="0">
               <a:buNone/>
             </a:pPr>
             <a:r>
-              <a:rPr lang="en-US" sz="1400" b="1" dirty="0">
+              <a:rPr lang="en-US" sz="1100" dirty="0">
                 <a:solidFill>
                   <a:schemeClr val="tx1"/>
                 </a:solidFill>
               </a:rPr>
-              <a:t>Cat6 / Cat7 בשרשרת</a:t>
-            </a:r>
-            <a:endParaRPr lang="en-US" sz="1400" dirty="0"/>
-          </a:p>
-        </p:txBody>
-      </p:sp>
-      <p:sp>
-        <p:nvSpPr>
-          <p:cNvPr id="10" name="Text 6"/>
+              <a:t>LCom ← LCom ← Buscomm בארון הקומה</a:t>
+            </a:r>
+            <a:endParaRPr lang="en-US" sz="1100" dirty="0"/>
+          </a:p>
+        </p:txBody>
+      </p:sp>
+      <p:sp>
+        <p:nvSpPr>
+          <p:cNvPr id="13" name="paso 4"/>
+          <p:cNvSpPr/>
+          <p:nvPr/>
+        </p:nvSpPr>
+        <p:spPr>
+          <a:xfrm>
+            <a:off x="6172200" y="5349240"/>
+            <a:ext cx="384048" cy="384048"/>
+          </a:xfrm>
+          <a:prstGeom prst="ellipse">
+            <a:avLst/>
+          </a:prstGeom>
+          <a:solidFill>
+            <a:schemeClr val="accent1"/>
+          </a:solidFill>
+          <a:ln w="12700">
+            <a:solidFill>
+              <a:schemeClr val="accent1"/>
+            </a:solidFill>
+            <a:prstDash val="solid"/>
+          </a:ln>
+        </p:spPr>
+      </p:sp>
+      <p:sp>
+        <p:nvSpPr>
+          <p:cNvPr id="14" name="Text 11"/>
           <p:cNvSpPr txBox="1"/>
           <p:nvPr/>
         </p:nvSpPr>
         <p:spPr>
           <a:xfrm>
-            <a:off x="3017520" y="5303520"/>
-            <a:ext cx="2331720" cy="822960"/>
+            <a:off x="6172200" y="5349240"/>
+            <a:ext cx="384048" cy="384048"/>
+          </a:xfrm>
+          <a:prstGeom prst="rect">
+            <a:avLst/>
+          </a:prstGeom>
+          <a:noFill/>
+          <a:ln/>
+        </p:spPr>
+        <p:txBody>
+          <a:bodyPr wrap="square" lIns="0" tIns="0" rIns="0" bIns="0" rtlCol="0" anchor="ctr"/>
+          <a:lstStyle/>
+          <a:p>
+            <a:pPr algn="ctr" indent="0" marL="0">
+              <a:buNone/>
+            </a:pPr>
+            <a:r>
+              <a:rPr lang="en-US" sz="1300" b="1" dirty="0">
+                <a:solidFill>
+                  <a:schemeClr val="bg1"/>
+                </a:solidFill>
+              </a:rPr>
+              <a:t>4</a:t>
+            </a:r>
+            <a:endParaRPr lang="en-US" sz="1300" dirty="0"/>
+          </a:p>
+        </p:txBody>
+      </p:sp>
+      <p:sp>
+        <p:nvSpPr>
+          <p:cNvPr id="15" name="Text 12"/>
+          <p:cNvSpPr txBox="1"/>
+          <p:nvPr/>
+        </p:nvSpPr>
+        <p:spPr>
+          <a:xfrm>
+            <a:off x="6629400" y="5257800"/>
+            <a:ext cx="1371600" cy="1005840"/>
           </a:xfrm>
           <a:prstGeom prst="rect">
             <a:avLst/>
@@ -7429,37 +8190,37 @@
               <a:buNone/>
             </a:pPr>
             <a:r>
-              <a:rPr lang="en-US" sz="1200" dirty="0">
-                <a:solidFill>
-                  <a:schemeClr val="tx2"/>
+              <a:rPr lang="en-US" sz="1100" dirty="0">
+                <a:solidFill>
+                  <a:schemeClr val="tx1"/>
                 </a:solidFill>
               </a:rPr>
-              <a:t>x01 ← x04 ← שירותים ציבוריים · x02 ← x03</a:t>
-            </a:r>
-            <a:endParaRPr lang="en-US" sz="1200" dirty="0"/>
-          </a:p>
-        </p:txBody>
-      </p:sp>
-      <p:sp>
-        <p:nvSpPr>
-          <p:cNvPr id="11" name="color 2"/>
+              <a:t>Buscomm ← מתג PoE של הקומה</a:t>
+            </a:r>
+            <a:endParaRPr lang="en-US" sz="1100" dirty="0"/>
+          </a:p>
+        </p:txBody>
+      </p:sp>
+      <p:sp>
+        <p:nvSpPr>
+          <p:cNvPr id="16" name="paso 5"/>
           <p:cNvSpPr/>
           <p:nvPr/>
         </p:nvSpPr>
         <p:spPr>
           <a:xfrm>
-            <a:off x="5486400" y="4709160"/>
-            <a:ext cx="502920" cy="109728"/>
-          </a:xfrm>
-          <a:prstGeom prst="rect">
+            <a:off x="8046720" y="5349240"/>
+            <a:ext cx="384048" cy="384048"/>
+          </a:xfrm>
+          <a:prstGeom prst="ellipse">
             <a:avLst/>
           </a:prstGeom>
           <a:solidFill>
-            <a:schemeClr val="accent4"/>
+            <a:schemeClr val="accent1"/>
           </a:solidFill>
           <a:ln w="12700">
             <a:solidFill>
-              <a:schemeClr val="accent4"/>
+              <a:schemeClr val="accent1"/>
             </a:solidFill>
             <a:prstDash val="solid"/>
           </a:ln>
@@ -7467,14 +8228,14 @@
       </p:sp>
       <p:sp>
         <p:nvSpPr>
-          <p:cNvPr id="12" name="Text 8"/>
+          <p:cNvPr id="17" name="Text 14"/>
           <p:cNvSpPr txBox="1"/>
           <p:nvPr/>
         </p:nvSpPr>
         <p:spPr>
           <a:xfrm>
-            <a:off x="5486400" y="4892040"/>
-            <a:ext cx="2331720" cy="365760"/>
+            <a:off x="8046720" y="5349240"/>
+            <a:ext cx="384048" cy="384048"/>
           </a:xfrm>
           <a:prstGeom prst="rect">
             <a:avLst/>
@@ -7484,33 +8245,130 @@
         </p:spPr>
         <p:txBody>
           <a:bodyPr wrap="square" lIns="0" tIns="0" rIns="0" bIns="0" rtlCol="0" anchor="ctr"/>
+          <a:lstStyle/>
+          <a:p>
+            <a:pPr algn="ctr" indent="0" marL="0">
+              <a:buNone/>
+            </a:pPr>
+            <a:r>
+              <a:rPr lang="en-US" sz="1300" b="1" dirty="0">
+                <a:solidFill>
+                  <a:schemeClr val="bg1"/>
+                </a:solidFill>
+              </a:rPr>
+              <a:t>5</a:t>
+            </a:r>
+            <a:endParaRPr lang="en-US" sz="1300" dirty="0"/>
+          </a:p>
+        </p:txBody>
+      </p:sp>
+      <p:sp>
+        <p:nvSpPr>
+          <p:cNvPr id="18" name="Text 15"/>
+          <p:cNvSpPr txBox="1"/>
+          <p:nvPr/>
+        </p:nvSpPr>
+        <p:spPr>
+          <a:xfrm>
+            <a:off x="8503920" y="5257800"/>
+            <a:ext cx="1371600" cy="1005840"/>
+          </a:xfrm>
+          <a:prstGeom prst="rect">
+            <a:avLst/>
+          </a:prstGeom>
+          <a:noFill/>
+          <a:ln/>
+        </p:spPr>
+        <p:txBody>
+          <a:bodyPr wrap="square" lIns="0" tIns="0" rIns="0" bIns="0" rtlCol="0" anchor="t"/>
           <a:lstStyle/>
           <a:p>
             <a:pPr rtl="1" indent="0" marL="0">
               <a:buNone/>
             </a:pPr>
             <a:r>
-              <a:rPr lang="en-US" sz="1400" b="1" dirty="0">
+              <a:rPr lang="en-US" sz="1100" dirty="0">
                 <a:solidFill>
                   <a:schemeClr val="tx1"/>
                 </a:solidFill>
               </a:rPr>
-              <a:t>Cat6A / Cat7 רשת</a:t>
-            </a:r>
-            <a:endParaRPr lang="en-US" sz="1400" dirty="0"/>
-          </a:p>
-        </p:txBody>
-      </p:sp>
-      <p:sp>
-        <p:nvSpPr>
-          <p:cNvPr id="13" name="Text 9"/>
+              <a:t>מתגים דרך העמוד ← שרת קרקע</a:t>
+            </a:r>
+            <a:endParaRPr lang="en-US" sz="1100" dirty="0"/>
+          </a:p>
+        </p:txBody>
+      </p:sp>
+      <p:sp>
+        <p:nvSpPr>
+          <p:cNvPr id="19" name="paso 6"/>
+          <p:cNvSpPr/>
+          <p:nvPr/>
+        </p:nvSpPr>
+        <p:spPr>
+          <a:xfrm>
+            <a:off x="9921240" y="5349240"/>
+            <a:ext cx="384048" cy="384048"/>
+          </a:xfrm>
+          <a:prstGeom prst="ellipse">
+            <a:avLst/>
+          </a:prstGeom>
+          <a:solidFill>
+            <a:schemeClr val="accent1"/>
+          </a:solidFill>
+          <a:ln w="12700">
+            <a:solidFill>
+              <a:schemeClr val="accent1"/>
+            </a:solidFill>
+            <a:prstDash val="solid"/>
+          </a:ln>
+        </p:spPr>
+      </p:sp>
+      <p:sp>
+        <p:nvSpPr>
+          <p:cNvPr id="20" name="Text 17"/>
           <p:cNvSpPr txBox="1"/>
           <p:nvPr/>
         </p:nvSpPr>
         <p:spPr>
           <a:xfrm>
-            <a:off x="5486400" y="5303520"/>
-            <a:ext cx="2331720" cy="822960"/>
+            <a:off x="9921240" y="5349240"/>
+            <a:ext cx="384048" cy="384048"/>
+          </a:xfrm>
+          <a:prstGeom prst="rect">
+            <a:avLst/>
+          </a:prstGeom>
+          <a:noFill/>
+          <a:ln/>
+        </p:spPr>
+        <p:txBody>
+          <a:bodyPr wrap="square" lIns="0" tIns="0" rIns="0" bIns="0" rtlCol="0" anchor="ctr"/>
+          <a:lstStyle/>
+          <a:p>
+            <a:pPr algn="ctr" indent="0" marL="0">
+              <a:buNone/>
+            </a:pPr>
+            <a:r>
+              <a:rPr lang="en-US" sz="1300" b="1" dirty="0">
+                <a:solidFill>
+                  <a:schemeClr val="bg1"/>
+                </a:solidFill>
+              </a:rPr>
+              <a:t>6</a:t>
+            </a:r>
+            <a:endParaRPr lang="en-US" sz="1300" dirty="0"/>
+          </a:p>
+        </p:txBody>
+      </p:sp>
+      <p:sp>
+        <p:nvSpPr>
+          <p:cNvPr id="21" name="Text 18"/>
+          <p:cNvSpPr txBox="1"/>
+          <p:nvPr/>
+        </p:nvSpPr>
+        <p:spPr>
+          <a:xfrm>
+            <a:off x="10378440" y="5257800"/>
+            <a:ext cx="1371600" cy="1005840"/>
           </a:xfrm>
           <a:prstGeom prst="rect">
             <a:avLst/>
@@ -7526,14 +8384,14 @@
               <a:buNone/>
             </a:pPr>
             <a:r>
-              <a:rPr lang="en-US" sz="1200" dirty="0">
-                <a:solidFill>
-                  <a:schemeClr val="tx2"/>
+              <a:rPr lang="en-US" sz="1100" dirty="0">
+                <a:solidFill>
+                  <a:schemeClr val="tx1"/>
                 </a:solidFill>
               </a:rPr>
-              <a:t>Buscomm ← מתג ← עמוד ← שרת</a:t>
-            </a:r>
-            <a:endParaRPr lang="en-US" sz="1200" dirty="0"/>
+              <a:t>שיחה קולית בטלפון האנדרואיד בעמדה</a:t>
+            </a:r>
+            <a:endParaRPr lang="en-US" sz="1100" dirty="0"/>
           </a:p>
         </p:txBody>
       </p:sp>

</xml_diff>